<commit_message>
Update interview presentation with latest evaluation
</commit_message>
<xml_diff>
--- a/presentations/Churn_Prediction_Explainability_Fairness_KKBox_Interview_Final.pptx
+++ b/presentations/Churn_Prediction_Explainability_Fairness_KKBox_Interview_Final.pptx
@@ -2,18 +2,18 @@
 <file path=ppt/presentation.xml><?xml version="1.0" encoding="utf-8"?>
 <p:presentation xmlns:p="http://schemas.openxmlformats.org/presentationml/2006/main">
   <p:sldMasterIdLst>
-    <p:sldMasterId xmlns:r="http://schemas.openxmlformats.org/officeDocument/2006/relationships" id="2147483648" r:id="R884f1a377d4e4ff9"/>
+    <p:sldMasterId xmlns:r="http://schemas.openxmlformats.org/officeDocument/2006/relationships" id="2147483648" r:id="R68ab798d04a84ea9"/>
   </p:sldMasterIdLst>
   <p:notesMasterIdLst>
-    <p:notesMasterId xmlns:r="http://schemas.openxmlformats.org/officeDocument/2006/relationships" r:id="R74f92de191994862"/>
+    <p:notesMasterId xmlns:r="http://schemas.openxmlformats.org/officeDocument/2006/relationships" r:id="Rd2541215ccda4d84"/>
   </p:notesMasterIdLst>
   <p:sldIdLst>
-    <p:sldId xmlns:r="http://schemas.openxmlformats.org/officeDocument/2006/relationships" id="256" r:id="Rd8f97e302a7a4e79"/>
-    <p:sldId xmlns:r="http://schemas.openxmlformats.org/officeDocument/2006/relationships" id="257" r:id="Rb0429c94d783473f"/>
-    <p:sldId xmlns:r="http://schemas.openxmlformats.org/officeDocument/2006/relationships" id="258" r:id="R683bfbf823f74a72"/>
-    <p:sldId xmlns:r="http://schemas.openxmlformats.org/officeDocument/2006/relationships" id="259" r:id="Red4e88127e59455f"/>
-    <p:sldId xmlns:r="http://schemas.openxmlformats.org/officeDocument/2006/relationships" id="260" r:id="Re5f399d1144a42e8"/>
-    <p:sldId xmlns:r="http://schemas.openxmlformats.org/officeDocument/2006/relationships" id="261" r:id="R35f76d6277e24e80"/>
+    <p:sldId xmlns:r="http://schemas.openxmlformats.org/officeDocument/2006/relationships" id="256" r:id="Ree99933a9ff146bd"/>
+    <p:sldId xmlns:r="http://schemas.openxmlformats.org/officeDocument/2006/relationships" id="257" r:id="Rc068592dcb4a4e80"/>
+    <p:sldId xmlns:r="http://schemas.openxmlformats.org/officeDocument/2006/relationships" id="258" r:id="Rf51e52ab3d244176"/>
+    <p:sldId xmlns:r="http://schemas.openxmlformats.org/officeDocument/2006/relationships" id="259" r:id="Rd38c2152968a46d5"/>
+    <p:sldId xmlns:r="http://schemas.openxmlformats.org/officeDocument/2006/relationships" id="260" r:id="R6693be7aebe74e70"/>
+    <p:sldId xmlns:r="http://schemas.openxmlformats.org/officeDocument/2006/relationships" id="261" r:id="R8975e08898fc4474"/>
   </p:sldIdLst>
   <p:sldSz cx="12192000" cy="6858000"/>
   <p:notesSz cx="6858000" cy="9144000"/>
@@ -844,7 +844,7 @@
           <p:cNvPr id="3" name="Title">
             <a:extLst xmlns:a="http://schemas.openxmlformats.org/drawingml/2006/main">
               <a:ext uri="{FF2B5EF4-FFF2-40B4-BE49-F238E27FC236}">
-                <a16:creationId xmlns:a16="http://schemas.microsoft.com/office/drawing/2014/main" id="{DF9F9328-6880-499A-957F-0A6F536D7181}"/>
+                <a16:creationId xmlns:a16="http://schemas.microsoft.com/office/drawing/2014/main" id="{AC362651-1A6B-47C3-9C04-82ACE60E9522}"/>
               </a:ext>
             </a:extLst>
           </p:cNvPr>
@@ -1001,7 +1001,7 @@
           <p:cNvPr id="2" name="Subtitle">
             <a:extLst xmlns:a="http://schemas.openxmlformats.org/drawingml/2006/main">
               <a:ext uri="{FF2B5EF4-FFF2-40B4-BE49-F238E27FC236}">
-                <a16:creationId xmlns:a16="http://schemas.microsoft.com/office/drawing/2014/main" id="{1B75C5F1-8A13-4A00-9FB4-6F7BCB44E749}"/>
+                <a16:creationId xmlns:a16="http://schemas.microsoft.com/office/drawing/2014/main" id="{D843D196-3D22-4360-AC21-77AC55D87A9E}"/>
               </a:ext>
             </a:extLst>
           </p:cNvPr>
@@ -1175,7 +1175,7 @@
           <p:cNvPr id="2" name="Section title">
             <a:extLst xmlns:a="http://schemas.openxmlformats.org/drawingml/2006/main">
               <a:ext uri="{FF2B5EF4-FFF2-40B4-BE49-F238E27FC236}">
-                <a16:creationId xmlns:a16="http://schemas.microsoft.com/office/drawing/2014/main" id="{69FA0F7F-417F-4497-9E40-E9977E772583}"/>
+                <a16:creationId xmlns:a16="http://schemas.microsoft.com/office/drawing/2014/main" id="{E72FA8FE-754D-47A5-BFCA-2F4229C1664F}"/>
               </a:ext>
             </a:extLst>
           </p:cNvPr>
@@ -1349,7 +1349,7 @@
           <p:cNvPr id="3" name="Title">
             <a:extLst xmlns:a="http://schemas.openxmlformats.org/drawingml/2006/main">
               <a:ext uri="{FF2B5EF4-FFF2-40B4-BE49-F238E27FC236}">
-                <a16:creationId xmlns:a16="http://schemas.microsoft.com/office/drawing/2014/main" id="{8053F08B-A30F-4A37-9AB5-6E3C9494C976}"/>
+                <a16:creationId xmlns:a16="http://schemas.microsoft.com/office/drawing/2014/main" id="{FDB943FE-61CD-4778-9939-99E576D0C432}"/>
               </a:ext>
             </a:extLst>
           </p:cNvPr>
@@ -1506,7 +1506,7 @@
           <p:cNvPr id="2" name="Body">
             <a:extLst xmlns:a="http://schemas.openxmlformats.org/drawingml/2006/main">
               <a:ext uri="{FF2B5EF4-FFF2-40B4-BE49-F238E27FC236}">
-                <a16:creationId xmlns:a16="http://schemas.microsoft.com/office/drawing/2014/main" id="{1DCD4E1F-4420-4411-80FF-4E241072AC45}"/>
+                <a16:creationId xmlns:a16="http://schemas.microsoft.com/office/drawing/2014/main" id="{F0099753-AE73-4EAB-96B7-1D2FDFCA6A1B}"/>
               </a:ext>
             </a:extLst>
           </p:cNvPr>
@@ -1680,7 +1680,7 @@
           <p:cNvPr id="4" name="Title">
             <a:extLst xmlns:a="http://schemas.openxmlformats.org/drawingml/2006/main">
               <a:ext uri="{FF2B5EF4-FFF2-40B4-BE49-F238E27FC236}">
-                <a16:creationId xmlns:a16="http://schemas.microsoft.com/office/drawing/2014/main" id="{89EE4954-7A90-4947-A96D-D43073C2CD99}"/>
+                <a16:creationId xmlns:a16="http://schemas.microsoft.com/office/drawing/2014/main" id="{2D225DD9-262A-42A6-9BB3-8524B0268344}"/>
               </a:ext>
             </a:extLst>
           </p:cNvPr>
@@ -1837,7 +1837,7 @@
           <p:cNvPr id="2" name="Left column">
             <a:extLst xmlns:a="http://schemas.openxmlformats.org/drawingml/2006/main">
               <a:ext uri="{FF2B5EF4-FFF2-40B4-BE49-F238E27FC236}">
-                <a16:creationId xmlns:a16="http://schemas.microsoft.com/office/drawing/2014/main" id="{17726DF3-81F0-42CD-99D0-3EDF3BD0943B}"/>
+                <a16:creationId xmlns:a16="http://schemas.microsoft.com/office/drawing/2014/main" id="{1F116781-D99C-4845-AA8B-D1C7E9C00B91}"/>
               </a:ext>
             </a:extLst>
           </p:cNvPr>
@@ -1994,7 +1994,7 @@
           <p:cNvPr id="3" name="Right column">
             <a:extLst xmlns:a="http://schemas.openxmlformats.org/drawingml/2006/main">
               <a:ext uri="{FF2B5EF4-FFF2-40B4-BE49-F238E27FC236}">
-                <a16:creationId xmlns:a16="http://schemas.microsoft.com/office/drawing/2014/main" id="{31E61D33-AD35-4B7D-B57A-77598F38AA13}"/>
+                <a16:creationId xmlns:a16="http://schemas.microsoft.com/office/drawing/2014/main" id="{3B6E2838-419E-47B9-A8E1-CAF9A0FAC396}"/>
               </a:ext>
             </a:extLst>
           </p:cNvPr>
@@ -2168,7 +2168,7 @@
           <p:cNvPr id="3" name="Title">
             <a:extLst xmlns:a="http://schemas.openxmlformats.org/drawingml/2006/main">
               <a:ext uri="{FF2B5EF4-FFF2-40B4-BE49-F238E27FC236}">
-                <a16:creationId xmlns:a16="http://schemas.microsoft.com/office/drawing/2014/main" id="{CE1EED16-661C-4243-B74E-C9F425BCC7F3}"/>
+                <a16:creationId xmlns:a16="http://schemas.microsoft.com/office/drawing/2014/main" id="{6541B588-D52F-4DA2-8FC1-6A6C308B6707}"/>
               </a:ext>
             </a:extLst>
           </p:cNvPr>
@@ -2325,7 +2325,7 @@
           <p:cNvPr id="2" name="Left column">
             <a:extLst xmlns:a="http://schemas.openxmlformats.org/drawingml/2006/main">
               <a:ext uri="{FF2B5EF4-FFF2-40B4-BE49-F238E27FC236}">
-                <a16:creationId xmlns:a16="http://schemas.microsoft.com/office/drawing/2014/main" id="{B4A8F23F-FE09-45AB-859E-977E1A7348B4}"/>
+                <a16:creationId xmlns:a16="http://schemas.microsoft.com/office/drawing/2014/main" id="{3DB94CF8-1A71-4ADF-BF0B-D3F5CAC9DF16}"/>
               </a:ext>
             </a:extLst>
           </p:cNvPr>
@@ -2520,12 +2520,12 @@
   </p:cSld>
   <p:clrMap bg1="lt1" tx1="dk1" bg2="lt2" tx2="dk2" accent1="accent1" accent2="accent2" accent3="accent3" accent4="accent4" accent5="accent5" accent6="accent6" hlink="hlink" folHlink="folHlink"/>
   <p:sldLayoutIdLst>
-    <p:sldLayoutId xmlns:r="http://schemas.openxmlformats.org/officeDocument/2006/relationships" id="2147483649" r:id="Rc6a22a43a144424a"/>
-    <p:sldLayoutId xmlns:r="http://schemas.openxmlformats.org/officeDocument/2006/relationships" id="2147483650" r:id="R23a8c622f6284312"/>
-    <p:sldLayoutId xmlns:r="http://schemas.openxmlformats.org/officeDocument/2006/relationships" id="2147483651" r:id="R070b70fdda3e4aa5"/>
-    <p:sldLayoutId xmlns:r="http://schemas.openxmlformats.org/officeDocument/2006/relationships" id="2147483652" r:id="R116327aaa83840ff"/>
-    <p:sldLayoutId xmlns:r="http://schemas.openxmlformats.org/officeDocument/2006/relationships" id="2147483653" r:id="Rda0ca0c09d214a90"/>
-    <p:sldLayoutId xmlns:r="http://schemas.openxmlformats.org/officeDocument/2006/relationships" id="2147483654" r:id="R5cfc79716894467f"/>
+    <p:sldLayoutId xmlns:r="http://schemas.openxmlformats.org/officeDocument/2006/relationships" id="2147483649" r:id="R1c2ca63f081849b2"/>
+    <p:sldLayoutId xmlns:r="http://schemas.openxmlformats.org/officeDocument/2006/relationships" id="2147483650" r:id="R50537d3d260849e8"/>
+    <p:sldLayoutId xmlns:r="http://schemas.openxmlformats.org/officeDocument/2006/relationships" id="2147483651" r:id="Rd94fb6deb06f4fb6"/>
+    <p:sldLayoutId xmlns:r="http://schemas.openxmlformats.org/officeDocument/2006/relationships" id="2147483652" r:id="Re05ad2ecbaa84000"/>
+    <p:sldLayoutId xmlns:r="http://schemas.openxmlformats.org/officeDocument/2006/relationships" id="2147483653" r:id="R15d5e26f1e4f47ca"/>
+    <p:sldLayoutId xmlns:r="http://schemas.openxmlformats.org/officeDocument/2006/relationships" id="2147483654" r:id="R7337f2ef40334245"/>
   </p:sldLayoutIdLst>
   <p:txStyles>
     <p:titleStyle>
@@ -3076,7 +3076,7 @@
           <p:cNvPr id="28" name="card">
             <a:extLst xmlns:a="http://schemas.openxmlformats.org/drawingml/2006/main">
               <a:ext uri="{FF2B5EF4-FFF2-40B4-BE49-F238E27FC236}">
-                <a16:creationId xmlns:a16="http://schemas.microsoft.com/office/drawing/2014/main" id="{082C7F1C-3C2B-46E6-B7DC-644BB471827F}"/>
+                <a16:creationId xmlns:a16="http://schemas.microsoft.com/office/drawing/2014/main" id="{285EDF10-BE85-446C-8C15-3B7CA8F7C78A}"/>
               </a:ext>
             </a:extLst>
           </p:cNvPr>
@@ -3107,7 +3107,7 @@
           <p:cNvPr id="2" name="card">
             <a:extLst xmlns:a="http://schemas.openxmlformats.org/drawingml/2006/main">
               <a:ext uri="{FF2B5EF4-FFF2-40B4-BE49-F238E27FC236}">
-                <a16:creationId xmlns:a16="http://schemas.microsoft.com/office/drawing/2014/main" id="{E9715F7C-56D3-4E63-946E-6320F7141CC7}"/>
+                <a16:creationId xmlns:a16="http://schemas.microsoft.com/office/drawing/2014/main" id="{FDB408C5-2741-475C-91FD-8A0773FCB2F9}"/>
               </a:ext>
             </a:extLst>
           </p:cNvPr>
@@ -3138,7 +3138,7 @@
           <p:cNvPr id="3" name="card">
             <a:extLst xmlns:a="http://schemas.openxmlformats.org/drawingml/2006/main">
               <a:ext uri="{FF2B5EF4-FFF2-40B4-BE49-F238E27FC236}">
-                <a16:creationId xmlns:a16="http://schemas.microsoft.com/office/drawing/2014/main" id="{80024674-5647-4A78-B9CF-68A258BE963A}"/>
+                <a16:creationId xmlns:a16="http://schemas.microsoft.com/office/drawing/2014/main" id="{FE9420CA-0F22-4430-B0D7-4DA3DCDAC49B}"/>
               </a:ext>
             </a:extLst>
           </p:cNvPr>
@@ -3169,7 +3169,7 @@
           <p:cNvPr id="4" name="card">
             <a:extLst xmlns:a="http://schemas.openxmlformats.org/drawingml/2006/main">
               <a:ext uri="{FF2B5EF4-FFF2-40B4-BE49-F238E27FC236}">
-                <a16:creationId xmlns:a16="http://schemas.microsoft.com/office/drawing/2014/main" id="{BD374BEB-F331-4728-99E1-F6A803697F57}"/>
+                <a16:creationId xmlns:a16="http://schemas.microsoft.com/office/drawing/2014/main" id="{DC464E6A-2732-40FA-8E89-8D07AA12125C}"/>
               </a:ext>
             </a:extLst>
           </p:cNvPr>
@@ -3200,7 +3200,7 @@
           <p:cNvPr id="5" name="card">
             <a:extLst xmlns:a="http://schemas.openxmlformats.org/drawingml/2006/main">
               <a:ext uri="{FF2B5EF4-FFF2-40B4-BE49-F238E27FC236}">
-                <a16:creationId xmlns:a16="http://schemas.microsoft.com/office/drawing/2014/main" id="{C297CC8D-C3A1-4ED3-85EE-7279F3ED431C}"/>
+                <a16:creationId xmlns:a16="http://schemas.microsoft.com/office/drawing/2014/main" id="{4ED2AED8-72CB-4B38-8A38-E510AF70BC32}"/>
               </a:ext>
             </a:extLst>
           </p:cNvPr>
@@ -3231,7 +3231,7 @@
           <p:cNvPr id="6" name="card">
             <a:extLst xmlns:a="http://schemas.openxmlformats.org/drawingml/2006/main">
               <a:ext uri="{FF2B5EF4-FFF2-40B4-BE49-F238E27FC236}">
-                <a16:creationId xmlns:a16="http://schemas.microsoft.com/office/drawing/2014/main" id="{891F227A-B1B3-4082-8D5F-72CBFB00A5C3}"/>
+                <a16:creationId xmlns:a16="http://schemas.microsoft.com/office/drawing/2014/main" id="{E4BCFC94-C72E-444D-9C1C-EF7C94B93428}"/>
               </a:ext>
             </a:extLst>
           </p:cNvPr>
@@ -3262,7 +3262,7 @@
           <p:cNvPr id="7" name="card">
             <a:extLst xmlns:a="http://schemas.openxmlformats.org/drawingml/2006/main">
               <a:ext uri="{FF2B5EF4-FFF2-40B4-BE49-F238E27FC236}">
-                <a16:creationId xmlns:a16="http://schemas.microsoft.com/office/drawing/2014/main" id="{340C7C1A-2D71-4D79-8840-84A48D63496A}"/>
+                <a16:creationId xmlns:a16="http://schemas.microsoft.com/office/drawing/2014/main" id="{E4E0506E-499A-44F6-A92B-694BBD8F3C20}"/>
               </a:ext>
             </a:extLst>
           </p:cNvPr>
@@ -3293,7 +3293,7 @@
           <p:cNvPr id="8" name="card">
             <a:extLst xmlns:a="http://schemas.openxmlformats.org/drawingml/2006/main">
               <a:ext uri="{FF2B5EF4-FFF2-40B4-BE49-F238E27FC236}">
-                <a16:creationId xmlns:a16="http://schemas.microsoft.com/office/drawing/2014/main" id="{29DCC5C8-EA1E-4CE9-99CD-AF7D7E3CF2BB}"/>
+                <a16:creationId xmlns:a16="http://schemas.microsoft.com/office/drawing/2014/main" id="{3CB8AA9D-C579-4725-B95F-AF1806A00C3B}"/>
               </a:ext>
             </a:extLst>
           </p:cNvPr>
@@ -3324,7 +3324,7 @@
           <p:cNvPr id="9" name="card">
             <a:extLst xmlns:a="http://schemas.openxmlformats.org/drawingml/2006/main">
               <a:ext uri="{FF2B5EF4-FFF2-40B4-BE49-F238E27FC236}">
-                <a16:creationId xmlns:a16="http://schemas.microsoft.com/office/drawing/2014/main" id="{6D6F4F94-4B2D-4BBD-A6A5-CEE27A537A50}"/>
+                <a16:creationId xmlns:a16="http://schemas.microsoft.com/office/drawing/2014/main" id="{B30A9231-0379-41C4-B5C9-FB6CBBE392DB}"/>
               </a:ext>
             </a:extLst>
           </p:cNvPr>
@@ -3355,7 +3355,7 @@
           <p:cNvPr id="10" name="card">
             <a:extLst xmlns:a="http://schemas.openxmlformats.org/drawingml/2006/main">
               <a:ext uri="{FF2B5EF4-FFF2-40B4-BE49-F238E27FC236}">
-                <a16:creationId xmlns:a16="http://schemas.microsoft.com/office/drawing/2014/main" id="{3D26D06E-3560-4C08-9CFC-AF7F800ECDC6}"/>
+                <a16:creationId xmlns:a16="http://schemas.microsoft.com/office/drawing/2014/main" id="{C5E80941-50C8-488E-9182-C433420171CE}"/>
               </a:ext>
             </a:extLst>
           </p:cNvPr>
@@ -3386,7 +3386,7 @@
           <p:cNvPr id="11" name="card">
             <a:extLst xmlns:a="http://schemas.openxmlformats.org/drawingml/2006/main">
               <a:ext uri="{FF2B5EF4-FFF2-40B4-BE49-F238E27FC236}">
-                <a16:creationId xmlns:a16="http://schemas.microsoft.com/office/drawing/2014/main" id="{F7076FD5-384E-4622-B02B-DD32A8C1EACF}"/>
+                <a16:creationId xmlns:a16="http://schemas.microsoft.com/office/drawing/2014/main" id="{FD92BECD-5B93-44FC-A585-784EC91BDB21}"/>
               </a:ext>
             </a:extLst>
           </p:cNvPr>
@@ -3417,7 +3417,7 @@
           <p:cNvPr id="12" name="card">
             <a:extLst xmlns:a="http://schemas.openxmlformats.org/drawingml/2006/main">
               <a:ext uri="{FF2B5EF4-FFF2-40B4-BE49-F238E27FC236}">
-                <a16:creationId xmlns:a16="http://schemas.microsoft.com/office/drawing/2014/main" id="{29006AE7-477B-4059-9BCC-FC4E30983857}"/>
+                <a16:creationId xmlns:a16="http://schemas.microsoft.com/office/drawing/2014/main" id="{693BC261-8A51-474D-B90D-1BB39379E5BA}"/>
               </a:ext>
             </a:extLst>
           </p:cNvPr>
@@ -3448,7 +3448,7 @@
           <p:cNvPr id="13" name="card">
             <a:extLst xmlns:a="http://schemas.openxmlformats.org/drawingml/2006/main">
               <a:ext uri="{FF2B5EF4-FFF2-40B4-BE49-F238E27FC236}">
-                <a16:creationId xmlns:a16="http://schemas.microsoft.com/office/drawing/2014/main" id="{4197A308-15FE-448B-A578-A096DDBF3CC9}"/>
+                <a16:creationId xmlns:a16="http://schemas.microsoft.com/office/drawing/2014/main" id="{442AE01B-2E74-411D-BBFF-2C51A6205EE9}"/>
               </a:ext>
             </a:extLst>
           </p:cNvPr>
@@ -3479,7 +3479,7 @@
           <p:cNvPr id="14" name="dot">
             <a:extLst xmlns:a="http://schemas.openxmlformats.org/drawingml/2006/main">
               <a:ext uri="{FF2B5EF4-FFF2-40B4-BE49-F238E27FC236}">
-                <a16:creationId xmlns:a16="http://schemas.microsoft.com/office/drawing/2014/main" id="{98684667-769F-4676-B2C2-03870CD3BF09}"/>
+                <a16:creationId xmlns:a16="http://schemas.microsoft.com/office/drawing/2014/main" id="{C2A88507-5815-4BC0-8C2E-41FFF72590DB}"/>
               </a:ext>
             </a:extLst>
           </p:cNvPr>
@@ -3510,7 +3510,7 @@
           <p:cNvPr id="15" name="dot">
             <a:extLst xmlns:a="http://schemas.openxmlformats.org/drawingml/2006/main">
               <a:ext uri="{FF2B5EF4-FFF2-40B4-BE49-F238E27FC236}">
-                <a16:creationId xmlns:a16="http://schemas.microsoft.com/office/drawing/2014/main" id="{8C7BA423-CB97-4828-B96A-CA2B0AFD3EE2}"/>
+                <a16:creationId xmlns:a16="http://schemas.microsoft.com/office/drawing/2014/main" id="{E2DC9B31-89BE-4A32-AD59-0279B135B886}"/>
               </a:ext>
             </a:extLst>
           </p:cNvPr>
@@ -3541,7 +3541,7 @@
           <p:cNvPr id="16" name="dot">
             <a:extLst xmlns:a="http://schemas.openxmlformats.org/drawingml/2006/main">
               <a:ext uri="{FF2B5EF4-FFF2-40B4-BE49-F238E27FC236}">
-                <a16:creationId xmlns:a16="http://schemas.microsoft.com/office/drawing/2014/main" id="{2CCB724C-DFA4-4468-B305-09D8AC85F9BC}"/>
+                <a16:creationId xmlns:a16="http://schemas.microsoft.com/office/drawing/2014/main" id="{94C10489-2F51-4B02-BA2F-99FB5F8A04AD}"/>
               </a:ext>
             </a:extLst>
           </p:cNvPr>
@@ -3572,7 +3572,7 @@
           <p:cNvPr id="17" name="dot">
             <a:extLst xmlns:a="http://schemas.openxmlformats.org/drawingml/2006/main">
               <a:ext uri="{FF2B5EF4-FFF2-40B4-BE49-F238E27FC236}">
-                <a16:creationId xmlns:a16="http://schemas.microsoft.com/office/drawing/2014/main" id="{35AB4623-E260-400E-90B0-9C0CBC54DF59}"/>
+                <a16:creationId xmlns:a16="http://schemas.microsoft.com/office/drawing/2014/main" id="{03B23010-085C-44FD-A0D2-27AB173EEBCE}"/>
               </a:ext>
             </a:extLst>
           </p:cNvPr>
@@ -3603,7 +3603,7 @@
           <p:cNvPr id="18" name="dot">
             <a:extLst xmlns:a="http://schemas.openxmlformats.org/drawingml/2006/main">
               <a:ext uri="{FF2B5EF4-FFF2-40B4-BE49-F238E27FC236}">
-                <a16:creationId xmlns:a16="http://schemas.microsoft.com/office/drawing/2014/main" id="{6F2FEFE9-B1BA-4745-A270-BBC77B3D5FB5}"/>
+                <a16:creationId xmlns:a16="http://schemas.microsoft.com/office/drawing/2014/main" id="{7E570ADF-B0D1-48DF-A909-0D9D4AF0561F}"/>
               </a:ext>
             </a:extLst>
           </p:cNvPr>
@@ -3634,7 +3634,7 @@
           <p:cNvPr id="19" name="card">
             <a:extLst xmlns:a="http://schemas.openxmlformats.org/drawingml/2006/main">
               <a:ext uri="{FF2B5EF4-FFF2-40B4-BE49-F238E27FC236}">
-                <a16:creationId xmlns:a16="http://schemas.microsoft.com/office/drawing/2014/main" id="{9D369465-A180-4011-B518-41DA39FC17EB}"/>
+                <a16:creationId xmlns:a16="http://schemas.microsoft.com/office/drawing/2014/main" id="{CF63D086-166E-4A4D-BB36-B475FB548738}"/>
               </a:ext>
             </a:extLst>
           </p:cNvPr>
@@ -3667,7 +3667,7 @@
           <p:cNvPr id="20" name="text">
             <a:extLst xmlns:a="http://schemas.openxmlformats.org/drawingml/2006/main">
               <a:ext uri="{FF2B5EF4-FFF2-40B4-BE49-F238E27FC236}">
-                <a16:creationId xmlns:a16="http://schemas.microsoft.com/office/drawing/2014/main" id="{15E1AF29-2192-45FA-9151-D48CDDFD8984}"/>
+                <a16:creationId xmlns:a16="http://schemas.microsoft.com/office/drawing/2014/main" id="{4A0F1FA5-9048-41E8-8661-2AAF586714A0}"/>
               </a:ext>
             </a:extLst>
           </p:cNvPr>
@@ -3736,7 +3736,7 @@
           <p:cNvPr id="21" name="cover-title">
             <a:extLst xmlns:a="http://schemas.openxmlformats.org/drawingml/2006/main">
               <a:ext uri="{FF2B5EF4-FFF2-40B4-BE49-F238E27FC236}">
-                <a16:creationId xmlns:a16="http://schemas.microsoft.com/office/drawing/2014/main" id="{EE224DC6-8548-4D1B-A856-57F7186DF4CC}"/>
+                <a16:creationId xmlns:a16="http://schemas.microsoft.com/office/drawing/2014/main" id="{47D01006-CB45-4A90-9BCD-7447FF172BEE}"/>
               </a:ext>
             </a:extLst>
           </p:cNvPr>
@@ -3851,7 +3851,7 @@
           <p:cNvPr id="22" name="text">
             <a:extLst xmlns:a="http://schemas.openxmlformats.org/drawingml/2006/main">
               <a:ext uri="{FF2B5EF4-FFF2-40B4-BE49-F238E27FC236}">
-                <a16:creationId xmlns:a16="http://schemas.microsoft.com/office/drawing/2014/main" id="{8CA37255-9DC6-47A9-9A2F-7884078C235D}"/>
+                <a16:creationId xmlns:a16="http://schemas.microsoft.com/office/drawing/2014/main" id="{46ED493D-ABA4-43CF-ADC4-F4D9D3F7F033}"/>
               </a:ext>
             </a:extLst>
           </p:cNvPr>
@@ -3920,7 +3920,7 @@
           <p:cNvPr id="23" name="text">
             <a:extLst xmlns:a="http://schemas.openxmlformats.org/drawingml/2006/main">
               <a:ext uri="{FF2B5EF4-FFF2-40B4-BE49-F238E27FC236}">
-                <a16:creationId xmlns:a16="http://schemas.microsoft.com/office/drawing/2014/main" id="{C24093F0-9414-4098-95D8-ED9B7B4BA6B3}"/>
+                <a16:creationId xmlns:a16="http://schemas.microsoft.com/office/drawing/2014/main" id="{AECA43E7-4336-4C52-B869-A74221624E3E}"/>
               </a:ext>
             </a:extLst>
           </p:cNvPr>
@@ -3989,7 +3989,7 @@
           <p:cNvPr id="24" name="card">
             <a:extLst xmlns:a="http://schemas.openxmlformats.org/drawingml/2006/main">
               <a:ext uri="{FF2B5EF4-FFF2-40B4-BE49-F238E27FC236}">
-                <a16:creationId xmlns:a16="http://schemas.microsoft.com/office/drawing/2014/main" id="{DDC2CFEB-7229-435D-825D-2B4D9740EDFA}"/>
+                <a16:creationId xmlns:a16="http://schemas.microsoft.com/office/drawing/2014/main" id="{386155FC-EBD5-4E9F-86D6-C7821FEB1C93}"/>
               </a:ext>
             </a:extLst>
           </p:cNvPr>
@@ -4022,7 +4022,7 @@
           <p:cNvPr id="25" name="text">
             <a:extLst xmlns:a="http://schemas.openxmlformats.org/drawingml/2006/main">
               <a:ext uri="{FF2B5EF4-FFF2-40B4-BE49-F238E27FC236}">
-                <a16:creationId xmlns:a16="http://schemas.microsoft.com/office/drawing/2014/main" id="{C613F909-C958-472A-ABE0-30661FFEB4C5}"/>
+                <a16:creationId xmlns:a16="http://schemas.microsoft.com/office/drawing/2014/main" id="{3A37271A-9E18-4DA0-8BE3-D723E3A19A9C}"/>
               </a:ext>
             </a:extLst>
           </p:cNvPr>
@@ -4091,7 +4091,7 @@
           <p:cNvPr id="26" name="text">
             <a:extLst xmlns:a="http://schemas.openxmlformats.org/drawingml/2006/main">
               <a:ext uri="{FF2B5EF4-FFF2-40B4-BE49-F238E27FC236}">
-                <a16:creationId xmlns:a16="http://schemas.microsoft.com/office/drawing/2014/main" id="{264DC304-9B5F-423C-8FC0-24E5B6E0ED48}"/>
+                <a16:creationId xmlns:a16="http://schemas.microsoft.com/office/drawing/2014/main" id="{58E1641A-EA17-44AA-8938-54AEC3ABB2EA}"/>
               </a:ext>
             </a:extLst>
           </p:cNvPr>
@@ -4160,7 +4160,7 @@
           <p:cNvPr id="27" name="text">
             <a:extLst xmlns:a="http://schemas.openxmlformats.org/drawingml/2006/main">
               <a:ext uri="{FF2B5EF4-FFF2-40B4-BE49-F238E27FC236}">
-                <a16:creationId xmlns:a16="http://schemas.microsoft.com/office/drawing/2014/main" id="{BFF29934-066C-4CE8-99CE-D9E005D7FC8E}"/>
+                <a16:creationId xmlns:a16="http://schemas.microsoft.com/office/drawing/2014/main" id="{CDB2EEC3-6182-4861-8C33-9B7C92CDFF5F}"/>
               </a:ext>
             </a:extLst>
           </p:cNvPr>
@@ -4227,7 +4227,7 @@
     </p:spTree>
     <p:extLst>
       <p:ext uri="{BB962C8B-B14F-4D97-AF65-F5344CB8AC3E}">
-        <p14:creationId xmlns:p14="http://schemas.microsoft.com/office/powerpoint/2010/main" val="2095352361"/>
+        <p14:creationId xmlns:p14="http://schemas.microsoft.com/office/powerpoint/2010/main" val="1831607157"/>
       </p:ext>
     </p:extLst>
   </p:cSld>
@@ -4258,7 +4258,7 @@
           <p:cNvPr id="29" name="slide-2-kicker">
             <a:extLst xmlns:a="http://schemas.openxmlformats.org/drawingml/2006/main">
               <a:ext uri="{FF2B5EF4-FFF2-40B4-BE49-F238E27FC236}">
-                <a16:creationId xmlns:a16="http://schemas.microsoft.com/office/drawing/2014/main" id="{36F4BFC2-47E1-4165-A761-FB621A910231}"/>
+                <a16:creationId xmlns:a16="http://schemas.microsoft.com/office/drawing/2014/main" id="{E069FCF1-F4B2-4209-AB93-228D78636A70}"/>
               </a:ext>
             </a:extLst>
           </p:cNvPr>
@@ -4327,7 +4327,7 @@
           <p:cNvPr id="2" name="slide-2-title">
             <a:extLst xmlns:a="http://schemas.openxmlformats.org/drawingml/2006/main">
               <a:ext uri="{FF2B5EF4-FFF2-40B4-BE49-F238E27FC236}">
-                <a16:creationId xmlns:a16="http://schemas.microsoft.com/office/drawing/2014/main" id="{7007DC9C-2518-47BA-95B7-1B7067B0DC7D}"/>
+                <a16:creationId xmlns:a16="http://schemas.microsoft.com/office/drawing/2014/main" id="{7CC78CB3-E1EA-40EB-8C55-7ABB81431FE1}"/>
               </a:ext>
             </a:extLst>
           </p:cNvPr>
@@ -4396,7 +4396,7 @@
           <p:cNvPr id="3" name="slide-2-rule">
             <a:extLst xmlns:a="http://schemas.openxmlformats.org/drawingml/2006/main">
               <a:ext uri="{FF2B5EF4-FFF2-40B4-BE49-F238E27FC236}">
-                <a16:creationId xmlns:a16="http://schemas.microsoft.com/office/drawing/2014/main" id="{B6823D59-6713-4EB8-B00F-DA3A5DF9EF39}"/>
+                <a16:creationId xmlns:a16="http://schemas.microsoft.com/office/drawing/2014/main" id="{886907B5-9318-4159-892C-416C2C4AE09C}"/>
               </a:ext>
             </a:extLst>
           </p:cNvPr>
@@ -4427,7 +4427,7 @@
           <p:cNvPr id="4" name="text">
             <a:extLst xmlns:a="http://schemas.openxmlformats.org/drawingml/2006/main">
               <a:ext uri="{FF2B5EF4-FFF2-40B4-BE49-F238E27FC236}">
-                <a16:creationId xmlns:a16="http://schemas.microsoft.com/office/drawing/2014/main" id="{2CE04482-DCDF-4020-8CBD-668F1F929C0B}"/>
+                <a16:creationId xmlns:a16="http://schemas.microsoft.com/office/drawing/2014/main" id="{BBDD8D2A-C8DC-4FAD-BDDB-5385063CB003}"/>
               </a:ext>
             </a:extLst>
           </p:cNvPr>
@@ -4496,7 +4496,7 @@
           <p:cNvPr id="5" name="text">
             <a:extLst xmlns:a="http://schemas.openxmlformats.org/drawingml/2006/main">
               <a:ext uri="{FF2B5EF4-FFF2-40B4-BE49-F238E27FC236}">
-                <a16:creationId xmlns:a16="http://schemas.microsoft.com/office/drawing/2014/main" id="{F211600C-EDF1-4381-B946-F4AD3CCFEA16}"/>
+                <a16:creationId xmlns:a16="http://schemas.microsoft.com/office/drawing/2014/main" id="{CAD2FC15-0658-4DAE-A6F2-613500122CD0}"/>
               </a:ext>
             </a:extLst>
           </p:cNvPr>
@@ -4565,7 +4565,7 @@
           <p:cNvPr id="6" name="text">
             <a:extLst xmlns:a="http://schemas.openxmlformats.org/drawingml/2006/main">
               <a:ext uri="{FF2B5EF4-FFF2-40B4-BE49-F238E27FC236}">
-                <a16:creationId xmlns:a16="http://schemas.microsoft.com/office/drawing/2014/main" id="{9A42356F-4BC5-47CB-95A3-194681BB46A1}"/>
+                <a16:creationId xmlns:a16="http://schemas.microsoft.com/office/drawing/2014/main" id="{B843941A-A652-44D9-AD48-0E1F315EB3E4}"/>
               </a:ext>
             </a:extLst>
           </p:cNvPr>
@@ -4634,7 +4634,7 @@
           <p:cNvPr id="7" name="card">
             <a:extLst xmlns:a="http://schemas.openxmlformats.org/drawingml/2006/main">
               <a:ext uri="{FF2B5EF4-FFF2-40B4-BE49-F238E27FC236}">
-                <a16:creationId xmlns:a16="http://schemas.microsoft.com/office/drawing/2014/main" id="{8DC52E15-23E3-401E-BB19-2839E03B09D0}"/>
+                <a16:creationId xmlns:a16="http://schemas.microsoft.com/office/drawing/2014/main" id="{51E54A4D-5095-4F3E-8D7B-38C00E466E5E}"/>
               </a:ext>
             </a:extLst>
           </p:cNvPr>
@@ -4669,7 +4669,7 @@
           <p:cNvPr id="8" name="card">
             <a:extLst xmlns:a="http://schemas.openxmlformats.org/drawingml/2006/main">
               <a:ext uri="{FF2B5EF4-FFF2-40B4-BE49-F238E27FC236}">
-                <a16:creationId xmlns:a16="http://schemas.microsoft.com/office/drawing/2014/main" id="{074561F4-F7B3-46E5-8B71-6EA4AC8A47A5}"/>
+                <a16:creationId xmlns:a16="http://schemas.microsoft.com/office/drawing/2014/main" id="{FA308FAC-B30C-4158-83AC-37653EBC1E24}"/>
               </a:ext>
             </a:extLst>
           </p:cNvPr>
@@ -4704,7 +4704,7 @@
           <p:cNvPr id="9" name="card">
             <a:extLst xmlns:a="http://schemas.openxmlformats.org/drawingml/2006/main">
               <a:ext uri="{FF2B5EF4-FFF2-40B4-BE49-F238E27FC236}">
-                <a16:creationId xmlns:a16="http://schemas.microsoft.com/office/drawing/2014/main" id="{990AF166-06F2-498E-885B-5FD1B0C6F4E8}"/>
+                <a16:creationId xmlns:a16="http://schemas.microsoft.com/office/drawing/2014/main" id="{84C7970C-0439-4FD4-B11B-10C728AF281D}"/>
               </a:ext>
             </a:extLst>
           </p:cNvPr>
@@ -4737,7 +4737,7 @@
           <p:cNvPr id="10" name="text">
             <a:extLst xmlns:a="http://schemas.openxmlformats.org/drawingml/2006/main">
               <a:ext uri="{FF2B5EF4-FFF2-40B4-BE49-F238E27FC236}">
-                <a16:creationId xmlns:a16="http://schemas.microsoft.com/office/drawing/2014/main" id="{B3A2D274-4C16-4154-9456-F727DE3EC070}"/>
+                <a16:creationId xmlns:a16="http://schemas.microsoft.com/office/drawing/2014/main" id="{4E03F75C-6CCB-4807-9720-12DE23073124}"/>
               </a:ext>
             </a:extLst>
           </p:cNvPr>
@@ -4806,7 +4806,7 @@
           <p:cNvPr id="11" name="card">
             <a:extLst xmlns:a="http://schemas.openxmlformats.org/drawingml/2006/main">
               <a:ext uri="{FF2B5EF4-FFF2-40B4-BE49-F238E27FC236}">
-                <a16:creationId xmlns:a16="http://schemas.microsoft.com/office/drawing/2014/main" id="{FE31714D-F6AC-430E-B8F3-60FB95CEB60B}"/>
+                <a16:creationId xmlns:a16="http://schemas.microsoft.com/office/drawing/2014/main" id="{51805288-4ABC-460B-BA56-6D49B32E094E}"/>
               </a:ext>
             </a:extLst>
           </p:cNvPr>
@@ -4839,7 +4839,7 @@
           <p:cNvPr id="12" name="text">
             <a:extLst xmlns:a="http://schemas.openxmlformats.org/drawingml/2006/main">
               <a:ext uri="{FF2B5EF4-FFF2-40B4-BE49-F238E27FC236}">
-                <a16:creationId xmlns:a16="http://schemas.microsoft.com/office/drawing/2014/main" id="{360F7DDE-D625-408A-B9D2-7E4D8970D230}"/>
+                <a16:creationId xmlns:a16="http://schemas.microsoft.com/office/drawing/2014/main" id="{CDC72A8B-33B9-4D7B-9F08-13E7BDE5F1D0}"/>
               </a:ext>
             </a:extLst>
           </p:cNvPr>
@@ -4908,7 +4908,7 @@
           <p:cNvPr id="13" name="text">
             <a:extLst xmlns:a="http://schemas.openxmlformats.org/drawingml/2006/main">
               <a:ext uri="{FF2B5EF4-FFF2-40B4-BE49-F238E27FC236}">
-                <a16:creationId xmlns:a16="http://schemas.microsoft.com/office/drawing/2014/main" id="{9A581C72-6AA1-4B01-B150-C1F6514323FC}"/>
+                <a16:creationId xmlns:a16="http://schemas.microsoft.com/office/drawing/2014/main" id="{47ED2AAE-61A4-4648-BAD6-12AB71539C70}"/>
               </a:ext>
             </a:extLst>
           </p:cNvPr>
@@ -4977,7 +4977,7 @@
           <p:cNvPr id="14" name="text">
             <a:extLst xmlns:a="http://schemas.openxmlformats.org/drawingml/2006/main">
               <a:ext uri="{FF2B5EF4-FFF2-40B4-BE49-F238E27FC236}">
-                <a16:creationId xmlns:a16="http://schemas.microsoft.com/office/drawing/2014/main" id="{406D6D8F-B97E-4F1A-BC76-234766E9F366}"/>
+                <a16:creationId xmlns:a16="http://schemas.microsoft.com/office/drawing/2014/main" id="{8E465122-825D-438F-9619-D496E3CC979E}"/>
               </a:ext>
             </a:extLst>
           </p:cNvPr>
@@ -5046,7 +5046,7 @@
           <p:cNvPr id="15" name="text">
             <a:extLst xmlns:a="http://schemas.openxmlformats.org/drawingml/2006/main">
               <a:ext uri="{FF2B5EF4-FFF2-40B4-BE49-F238E27FC236}">
-                <a16:creationId xmlns:a16="http://schemas.microsoft.com/office/drawing/2014/main" id="{CDC55B1C-EAD5-4EF6-8B4F-E378A2D0A564}"/>
+                <a16:creationId xmlns:a16="http://schemas.microsoft.com/office/drawing/2014/main" id="{BC921851-F6D2-400C-B0F1-593EDA51B10C}"/>
               </a:ext>
             </a:extLst>
           </p:cNvPr>
@@ -5115,7 +5115,7 @@
           <p:cNvPr id="16" name="text">
             <a:extLst xmlns:a="http://schemas.openxmlformats.org/drawingml/2006/main">
               <a:ext uri="{FF2B5EF4-FFF2-40B4-BE49-F238E27FC236}">
-                <a16:creationId xmlns:a16="http://schemas.microsoft.com/office/drawing/2014/main" id="{F2748325-27C8-4316-9679-436AED0D0065}"/>
+                <a16:creationId xmlns:a16="http://schemas.microsoft.com/office/drawing/2014/main" id="{F5BFC7A7-32A1-49E0-BC9D-63A3F621E153}"/>
               </a:ext>
             </a:extLst>
           </p:cNvPr>
@@ -5184,7 +5184,7 @@
           <p:cNvPr id="17" name="text">
             <a:extLst xmlns:a="http://schemas.openxmlformats.org/drawingml/2006/main">
               <a:ext uri="{FF2B5EF4-FFF2-40B4-BE49-F238E27FC236}">
-                <a16:creationId xmlns:a16="http://schemas.microsoft.com/office/drawing/2014/main" id="{F0D84140-D20E-41B5-BFC2-ADBF334B699A}"/>
+                <a16:creationId xmlns:a16="http://schemas.microsoft.com/office/drawing/2014/main" id="{93BB0421-9D2F-426A-8F84-EA92E6A67D6B}"/>
               </a:ext>
             </a:extLst>
           </p:cNvPr>
@@ -5253,7 +5253,7 @@
           <p:cNvPr id="18" name="text">
             <a:extLst xmlns:a="http://schemas.openxmlformats.org/drawingml/2006/main">
               <a:ext uri="{FF2B5EF4-FFF2-40B4-BE49-F238E27FC236}">
-                <a16:creationId xmlns:a16="http://schemas.microsoft.com/office/drawing/2014/main" id="{D1F69489-6BD3-4CA3-ABA4-B1A863B0E1CE}"/>
+                <a16:creationId xmlns:a16="http://schemas.microsoft.com/office/drawing/2014/main" id="{5AAA5A3C-E6F2-46F1-AC57-58F52D70BD4A}"/>
               </a:ext>
             </a:extLst>
           </p:cNvPr>
@@ -5322,7 +5322,7 @@
           <p:cNvPr id="19" name="card">
             <a:extLst xmlns:a="http://schemas.openxmlformats.org/drawingml/2006/main">
               <a:ext uri="{FF2B5EF4-FFF2-40B4-BE49-F238E27FC236}">
-                <a16:creationId xmlns:a16="http://schemas.microsoft.com/office/drawing/2014/main" id="{2766294F-1322-4A20-A1D4-20C55E487D91}"/>
+                <a16:creationId xmlns:a16="http://schemas.microsoft.com/office/drawing/2014/main" id="{A229516B-0C50-4E4D-B3C0-DCBBC957C998}"/>
               </a:ext>
             </a:extLst>
           </p:cNvPr>
@@ -5355,7 +5355,7 @@
           <p:cNvPr id="20" name="card">
             <a:extLst xmlns:a="http://schemas.openxmlformats.org/drawingml/2006/main">
               <a:ext uri="{FF2B5EF4-FFF2-40B4-BE49-F238E27FC236}">
-                <a16:creationId xmlns:a16="http://schemas.microsoft.com/office/drawing/2014/main" id="{7B91D6B0-84A9-4344-9BCB-BFFEC58C11BC}"/>
+                <a16:creationId xmlns:a16="http://schemas.microsoft.com/office/drawing/2014/main" id="{938F6A64-0F57-4110-A1BC-CA5CADF6F66F}"/>
               </a:ext>
             </a:extLst>
           </p:cNvPr>
@@ -5388,7 +5388,7 @@
           <p:cNvPr id="21" name="dot">
             <a:extLst xmlns:a="http://schemas.openxmlformats.org/drawingml/2006/main">
               <a:ext uri="{FF2B5EF4-FFF2-40B4-BE49-F238E27FC236}">
-                <a16:creationId xmlns:a16="http://schemas.microsoft.com/office/drawing/2014/main" id="{7943C841-2CCC-4B8A-BA8B-3BF6CAD7E320}"/>
+                <a16:creationId xmlns:a16="http://schemas.microsoft.com/office/drawing/2014/main" id="{E45FCA12-6118-487A-A067-43FD268C38C6}"/>
               </a:ext>
             </a:extLst>
           </p:cNvPr>
@@ -5419,7 +5419,7 @@
           <p:cNvPr id="22" name="dot">
             <a:extLst xmlns:a="http://schemas.openxmlformats.org/drawingml/2006/main">
               <a:ext uri="{FF2B5EF4-FFF2-40B4-BE49-F238E27FC236}">
-                <a16:creationId xmlns:a16="http://schemas.microsoft.com/office/drawing/2014/main" id="{940FFBEE-BEE5-4093-871E-B4C68CC09892}"/>
+                <a16:creationId xmlns:a16="http://schemas.microsoft.com/office/drawing/2014/main" id="{456A332D-A585-4907-8020-4F8059C4404F}"/>
               </a:ext>
             </a:extLst>
           </p:cNvPr>
@@ -5450,7 +5450,7 @@
           <p:cNvPr id="23" name="dot">
             <a:extLst xmlns:a="http://schemas.openxmlformats.org/drawingml/2006/main">
               <a:ext uri="{FF2B5EF4-FFF2-40B4-BE49-F238E27FC236}">
-                <a16:creationId xmlns:a16="http://schemas.microsoft.com/office/drawing/2014/main" id="{D049216F-7CD0-4513-8492-05411E84179D}"/>
+                <a16:creationId xmlns:a16="http://schemas.microsoft.com/office/drawing/2014/main" id="{7065BDBE-BD3D-4401-820F-BF3111C40C67}"/>
               </a:ext>
             </a:extLst>
           </p:cNvPr>
@@ -5481,7 +5481,7 @@
           <p:cNvPr id="24" name="text">
             <a:extLst xmlns:a="http://schemas.openxmlformats.org/drawingml/2006/main">
               <a:ext uri="{FF2B5EF4-FFF2-40B4-BE49-F238E27FC236}">
-                <a16:creationId xmlns:a16="http://schemas.microsoft.com/office/drawing/2014/main" id="{BA3641FB-2D16-4027-A0F7-CCB103DF890E}"/>
+                <a16:creationId xmlns:a16="http://schemas.microsoft.com/office/drawing/2014/main" id="{4A54BA6B-AC62-417F-BEE7-F33BD044352A}"/>
               </a:ext>
             </a:extLst>
           </p:cNvPr>
@@ -5550,7 +5550,7 @@
           <p:cNvPr id="25" name="text">
             <a:extLst xmlns:a="http://schemas.openxmlformats.org/drawingml/2006/main">
               <a:ext uri="{FF2B5EF4-FFF2-40B4-BE49-F238E27FC236}">
-                <a16:creationId xmlns:a16="http://schemas.microsoft.com/office/drawing/2014/main" id="{590D6000-C3BA-4A51-AC4F-31DCE6A93608}"/>
+                <a16:creationId xmlns:a16="http://schemas.microsoft.com/office/drawing/2014/main" id="{D93D04CD-DB35-4CA0-BD07-27B6CD0ECFBB}"/>
               </a:ext>
             </a:extLst>
           </p:cNvPr>
@@ -5619,7 +5619,7 @@
           <p:cNvPr id="26" name="text">
             <a:extLst xmlns:a="http://schemas.openxmlformats.org/drawingml/2006/main">
               <a:ext uri="{FF2B5EF4-FFF2-40B4-BE49-F238E27FC236}">
-                <a16:creationId xmlns:a16="http://schemas.microsoft.com/office/drawing/2014/main" id="{2E7B3442-9B3B-4BA8-A8C5-F1CA4D5CBD98}"/>
+                <a16:creationId xmlns:a16="http://schemas.microsoft.com/office/drawing/2014/main" id="{513EFB41-E749-4B73-BE56-14C19D09F7CB}"/>
               </a:ext>
             </a:extLst>
           </p:cNvPr>
@@ -5688,7 +5688,7 @@
           <p:cNvPr id="27" name="card">
             <a:extLst xmlns:a="http://schemas.openxmlformats.org/drawingml/2006/main">
               <a:ext uri="{FF2B5EF4-FFF2-40B4-BE49-F238E27FC236}">
-                <a16:creationId xmlns:a16="http://schemas.microsoft.com/office/drawing/2014/main" id="{318A5B0B-DA32-4068-861D-F5D8B841AF50}"/>
+                <a16:creationId xmlns:a16="http://schemas.microsoft.com/office/drawing/2014/main" id="{B638227E-2463-490B-9509-E40F0C56D594}"/>
               </a:ext>
             </a:extLst>
           </p:cNvPr>
@@ -5721,7 +5721,7 @@
           <p:cNvPr id="28" name="text">
             <a:extLst xmlns:a="http://schemas.openxmlformats.org/drawingml/2006/main">
               <a:ext uri="{FF2B5EF4-FFF2-40B4-BE49-F238E27FC236}">
-                <a16:creationId xmlns:a16="http://schemas.microsoft.com/office/drawing/2014/main" id="{8868355A-DC93-4490-AB2C-4C6A662D44DC}"/>
+                <a16:creationId xmlns:a16="http://schemas.microsoft.com/office/drawing/2014/main" id="{5A8979D8-A1D1-418E-B4AA-F8548E2410B2}"/>
               </a:ext>
             </a:extLst>
           </p:cNvPr>
@@ -5788,7 +5788,7 @@
     </p:spTree>
     <p:extLst>
       <p:ext uri="{BB962C8B-B14F-4D97-AF65-F5344CB8AC3E}">
-        <p14:creationId xmlns:p14="http://schemas.microsoft.com/office/powerpoint/2010/main" val="142868223"/>
+        <p14:creationId xmlns:p14="http://schemas.microsoft.com/office/powerpoint/2010/main" val="1171494235"/>
       </p:ext>
     </p:extLst>
   </p:cSld>
@@ -5816,10 +5816,10 @@
       </p:grpSpPr>
       <p:sp>
         <p:nvSpPr>
-          <p:cNvPr id="39" name="slide-3-kicker">
-            <a:extLst xmlns:a="http://schemas.openxmlformats.org/drawingml/2006/main">
-              <a:ext uri="{FF2B5EF4-FFF2-40B4-BE49-F238E27FC236}">
-                <a16:creationId xmlns:a16="http://schemas.microsoft.com/office/drawing/2014/main" id="{F02C3371-BA76-4A14-AEEC-54E35DF58CA8}"/>
+          <p:cNvPr id="37" name="slide-3-kicker">
+            <a:extLst xmlns:a="http://schemas.openxmlformats.org/drawingml/2006/main">
+              <a:ext uri="{FF2B5EF4-FFF2-40B4-BE49-F238E27FC236}">
+                <a16:creationId xmlns:a16="http://schemas.microsoft.com/office/drawing/2014/main" id="{5F8F03F3-016D-43E4-80DB-1DD322E921AB}"/>
               </a:ext>
             </a:extLst>
           </p:cNvPr>
@@ -5888,7 +5888,7 @@
           <p:cNvPr id="2" name="slide-3-title">
             <a:extLst xmlns:a="http://schemas.openxmlformats.org/drawingml/2006/main">
               <a:ext uri="{FF2B5EF4-FFF2-40B4-BE49-F238E27FC236}">
-                <a16:creationId xmlns:a16="http://schemas.microsoft.com/office/drawing/2014/main" id="{A7A3A729-C4E5-4090-82EA-DB25A6782B14}"/>
+                <a16:creationId xmlns:a16="http://schemas.microsoft.com/office/drawing/2014/main" id="{D4B6E8D7-1409-414E-81A7-C5D698FAA52D}"/>
               </a:ext>
             </a:extLst>
           </p:cNvPr>
@@ -5957,7 +5957,7 @@
           <p:cNvPr id="3" name="slide-3-rule">
             <a:extLst xmlns:a="http://schemas.openxmlformats.org/drawingml/2006/main">
               <a:ext uri="{FF2B5EF4-FFF2-40B4-BE49-F238E27FC236}">
-                <a16:creationId xmlns:a16="http://schemas.microsoft.com/office/drawing/2014/main" id="{5FEA009A-A610-4E4A-9F9F-E034A595FD66}"/>
+                <a16:creationId xmlns:a16="http://schemas.microsoft.com/office/drawing/2014/main" id="{22C2E790-03E9-4553-85DF-9315FAA2CEB0}"/>
               </a:ext>
             </a:extLst>
           </p:cNvPr>
@@ -5988,7 +5988,7 @@
           <p:cNvPr id="4" name="text">
             <a:extLst xmlns:a="http://schemas.openxmlformats.org/drawingml/2006/main">
               <a:ext uri="{FF2B5EF4-FFF2-40B4-BE49-F238E27FC236}">
-                <a16:creationId xmlns:a16="http://schemas.microsoft.com/office/drawing/2014/main" id="{D497BE90-1087-4DB0-BFEE-C01A3ADC32C7}"/>
+                <a16:creationId xmlns:a16="http://schemas.microsoft.com/office/drawing/2014/main" id="{ACFF2C0B-0E3B-4D46-A59A-027C0CF31F3A}"/>
               </a:ext>
             </a:extLst>
           </p:cNvPr>
@@ -6057,7 +6057,7 @@
           <p:cNvPr id="5" name="text">
             <a:extLst xmlns:a="http://schemas.openxmlformats.org/drawingml/2006/main">
               <a:ext uri="{FF2B5EF4-FFF2-40B4-BE49-F238E27FC236}">
-                <a16:creationId xmlns:a16="http://schemas.microsoft.com/office/drawing/2014/main" id="{8670279A-55C6-4D68-89E6-2C9D411CAB41}"/>
+                <a16:creationId xmlns:a16="http://schemas.microsoft.com/office/drawing/2014/main" id="{E8A5BAF9-6FFE-466F-9DDB-45618E62BF62}"/>
               </a:ext>
             </a:extLst>
           </p:cNvPr>
@@ -6126,7 +6126,7 @@
           <p:cNvPr id="6" name="text">
             <a:extLst xmlns:a="http://schemas.openxmlformats.org/drawingml/2006/main">
               <a:ext uri="{FF2B5EF4-FFF2-40B4-BE49-F238E27FC236}">
-                <a16:creationId xmlns:a16="http://schemas.microsoft.com/office/drawing/2014/main" id="{70B0D3B5-CD8A-4A37-AD48-FBCCC86E769E}"/>
+                <a16:creationId xmlns:a16="http://schemas.microsoft.com/office/drawing/2014/main" id="{A1213C5D-0B9A-4085-BC0A-8D534C311624}"/>
               </a:ext>
             </a:extLst>
           </p:cNvPr>
@@ -6195,7 +6195,7 @@
           <p:cNvPr id="7" name="metric-card">
             <a:extLst xmlns:a="http://schemas.openxmlformats.org/drawingml/2006/main">
               <a:ext uri="{FF2B5EF4-FFF2-40B4-BE49-F238E27FC236}">
-                <a16:creationId xmlns:a16="http://schemas.microsoft.com/office/drawing/2014/main" id="{430EA8C9-7FD8-47BC-84B3-F0D0E33E108D}"/>
+                <a16:creationId xmlns:a16="http://schemas.microsoft.com/office/drawing/2014/main" id="{E94F0AF7-7A5A-4584-9EF5-E736C5952490}"/>
               </a:ext>
             </a:extLst>
           </p:cNvPr>
@@ -6230,7 +6230,7 @@
           <p:cNvPr id="8" name="card">
             <a:extLst xmlns:a="http://schemas.openxmlformats.org/drawingml/2006/main">
               <a:ext uri="{FF2B5EF4-FFF2-40B4-BE49-F238E27FC236}">
-                <a16:creationId xmlns:a16="http://schemas.microsoft.com/office/drawing/2014/main" id="{3FB2D1F2-301C-4CD6-86CE-6454AA233C42}"/>
+                <a16:creationId xmlns:a16="http://schemas.microsoft.com/office/drawing/2014/main" id="{0765AF08-3510-4E74-895B-393D542D8B8E}"/>
               </a:ext>
             </a:extLst>
           </p:cNvPr>
@@ -6263,7 +6263,7 @@
           <p:cNvPr id="9" name="text">
             <a:extLst xmlns:a="http://schemas.openxmlformats.org/drawingml/2006/main">
               <a:ext uri="{FF2B5EF4-FFF2-40B4-BE49-F238E27FC236}">
-                <a16:creationId xmlns:a16="http://schemas.microsoft.com/office/drawing/2014/main" id="{60C8AF26-30A6-4E55-8738-0BC6CC0CEE4B}"/>
+                <a16:creationId xmlns:a16="http://schemas.microsoft.com/office/drawing/2014/main" id="{3853A7F0-5204-4D44-8E10-3B5E1ACCE952}"/>
               </a:ext>
             </a:extLst>
           </p:cNvPr>
@@ -6332,7 +6332,7 @@
           <p:cNvPr id="10" name="text">
             <a:extLst xmlns:a="http://schemas.openxmlformats.org/drawingml/2006/main">
               <a:ext uri="{FF2B5EF4-FFF2-40B4-BE49-F238E27FC236}">
-                <a16:creationId xmlns:a16="http://schemas.microsoft.com/office/drawing/2014/main" id="{AE29048E-88FA-43B4-AFC5-7A3F3B61D38D}"/>
+                <a16:creationId xmlns:a16="http://schemas.microsoft.com/office/drawing/2014/main" id="{DE5CC663-03F8-427E-BE34-C13888704A51}"/>
               </a:ext>
             </a:extLst>
           </p:cNvPr>
@@ -6401,7 +6401,7 @@
           <p:cNvPr id="11" name="text">
             <a:extLst xmlns:a="http://schemas.openxmlformats.org/drawingml/2006/main">
               <a:ext uri="{FF2B5EF4-FFF2-40B4-BE49-F238E27FC236}">
-                <a16:creationId xmlns:a16="http://schemas.microsoft.com/office/drawing/2014/main" id="{83E6F5FC-E737-49B3-9823-45DC6EA0A13A}"/>
+                <a16:creationId xmlns:a16="http://schemas.microsoft.com/office/drawing/2014/main" id="{7B03B44A-C972-40E2-BE70-72584C48F5AC}"/>
               </a:ext>
             </a:extLst>
           </p:cNvPr>
@@ -6460,7 +6460,7 @@
                 <a:ea typeface="Arial"/>
                 <a:cs typeface="Arial"/>
               </a:rPr>
-              <a:t>Logistic: 0.820  •  prior: 0.500</a:t>
+              <a:t>Prior baseline: 0.500</a:t>
             </a:r>
           </a:p>
         </p:txBody>
@@ -6470,7 +6470,7 @@
           <p:cNvPr id="12" name="metric-card">
             <a:extLst xmlns:a="http://schemas.openxmlformats.org/drawingml/2006/main">
               <a:ext uri="{FF2B5EF4-FFF2-40B4-BE49-F238E27FC236}">
-                <a16:creationId xmlns:a16="http://schemas.microsoft.com/office/drawing/2014/main" id="{59D029A0-2159-4D3F-9EC5-E065A7EC44C7}"/>
+                <a16:creationId xmlns:a16="http://schemas.microsoft.com/office/drawing/2014/main" id="{692E2607-EBE9-4528-8208-FCCD233E6D87}"/>
               </a:ext>
             </a:extLst>
           </p:cNvPr>
@@ -6505,7 +6505,7 @@
           <p:cNvPr id="13" name="card">
             <a:extLst xmlns:a="http://schemas.openxmlformats.org/drawingml/2006/main">
               <a:ext uri="{FF2B5EF4-FFF2-40B4-BE49-F238E27FC236}">
-                <a16:creationId xmlns:a16="http://schemas.microsoft.com/office/drawing/2014/main" id="{DCF839CF-DB83-4EE5-A7F9-91DA11B2F771}"/>
+                <a16:creationId xmlns:a16="http://schemas.microsoft.com/office/drawing/2014/main" id="{686DC8E5-E7EB-4892-BC36-0CA2B300BA50}"/>
               </a:ext>
             </a:extLst>
           </p:cNvPr>
@@ -6538,7 +6538,7 @@
           <p:cNvPr id="14" name="text">
             <a:extLst xmlns:a="http://schemas.openxmlformats.org/drawingml/2006/main">
               <a:ext uri="{FF2B5EF4-FFF2-40B4-BE49-F238E27FC236}">
-                <a16:creationId xmlns:a16="http://schemas.microsoft.com/office/drawing/2014/main" id="{62F152E0-3F20-4C6B-AED0-F1B2533281C6}"/>
+                <a16:creationId xmlns:a16="http://schemas.microsoft.com/office/drawing/2014/main" id="{375EFE80-EDB8-4114-B3BD-550BE46A54BC}"/>
               </a:ext>
             </a:extLst>
           </p:cNvPr>
@@ -6607,7 +6607,7 @@
           <p:cNvPr id="15" name="text">
             <a:extLst xmlns:a="http://schemas.openxmlformats.org/drawingml/2006/main">
               <a:ext uri="{FF2B5EF4-FFF2-40B4-BE49-F238E27FC236}">
-                <a16:creationId xmlns:a16="http://schemas.microsoft.com/office/drawing/2014/main" id="{51FA2682-4CBA-47CB-AD99-D3B764BD6A49}"/>
+                <a16:creationId xmlns:a16="http://schemas.microsoft.com/office/drawing/2014/main" id="{9578614B-7263-4FC1-B702-8DE07BE4ED39}"/>
               </a:ext>
             </a:extLst>
           </p:cNvPr>
@@ -6676,7 +6676,7 @@
           <p:cNvPr id="16" name="text">
             <a:extLst xmlns:a="http://schemas.openxmlformats.org/drawingml/2006/main">
               <a:ext uri="{FF2B5EF4-FFF2-40B4-BE49-F238E27FC236}">
-                <a16:creationId xmlns:a16="http://schemas.microsoft.com/office/drawing/2014/main" id="{FE88384C-6D5D-49C1-AD10-6EC4D2A4AEEA}"/>
+                <a16:creationId xmlns:a16="http://schemas.microsoft.com/office/drawing/2014/main" id="{B6331CB3-CFD0-44B9-97BA-6DAA325A37E5}"/>
               </a:ext>
             </a:extLst>
           </p:cNvPr>
@@ -6735,7 +6735,7 @@
                 <a:ea typeface="Arial"/>
                 <a:cs typeface="Arial"/>
               </a:rPr>
-              <a:t>Logistic: 0.460  •  prior: 0.090</a:t>
+              <a:t>Prior baseline: 0.090</a:t>
             </a:r>
           </a:p>
         </p:txBody>
@@ -6745,7 +6745,7 @@
           <p:cNvPr id="17" name="metric-card">
             <a:extLst xmlns:a="http://schemas.openxmlformats.org/drawingml/2006/main">
               <a:ext uri="{FF2B5EF4-FFF2-40B4-BE49-F238E27FC236}">
-                <a16:creationId xmlns:a16="http://schemas.microsoft.com/office/drawing/2014/main" id="{B3EC5332-8974-4CA6-B8CE-EB9BAD5FB3F6}"/>
+                <a16:creationId xmlns:a16="http://schemas.microsoft.com/office/drawing/2014/main" id="{81E61467-6E2E-4218-9986-48B281EE877A}"/>
               </a:ext>
             </a:extLst>
           </p:cNvPr>
@@ -6780,7 +6780,7 @@
           <p:cNvPr id="18" name="card">
             <a:extLst xmlns:a="http://schemas.openxmlformats.org/drawingml/2006/main">
               <a:ext uri="{FF2B5EF4-FFF2-40B4-BE49-F238E27FC236}">
-                <a16:creationId xmlns:a16="http://schemas.microsoft.com/office/drawing/2014/main" id="{EEC572B6-3F3D-484C-80E6-F77F59D66C40}"/>
+                <a16:creationId xmlns:a16="http://schemas.microsoft.com/office/drawing/2014/main" id="{E9FEF5C4-6D26-4219-B33A-E46A3A327FAC}"/>
               </a:ext>
             </a:extLst>
           </p:cNvPr>
@@ -6813,7 +6813,7 @@
           <p:cNvPr id="19" name="text">
             <a:extLst xmlns:a="http://schemas.openxmlformats.org/drawingml/2006/main">
               <a:ext uri="{FF2B5EF4-FFF2-40B4-BE49-F238E27FC236}">
-                <a16:creationId xmlns:a16="http://schemas.microsoft.com/office/drawing/2014/main" id="{7E6847E2-862D-4182-A008-EF43C71696B2}"/>
+                <a16:creationId xmlns:a16="http://schemas.microsoft.com/office/drawing/2014/main" id="{D16F3EE8-890B-4F64-96A1-83FDBAF0C211}"/>
               </a:ext>
             </a:extLst>
           </p:cNvPr>
@@ -6882,7 +6882,7 @@
           <p:cNvPr id="20" name="text">
             <a:extLst xmlns:a="http://schemas.openxmlformats.org/drawingml/2006/main">
               <a:ext uri="{FF2B5EF4-FFF2-40B4-BE49-F238E27FC236}">
-                <a16:creationId xmlns:a16="http://schemas.microsoft.com/office/drawing/2014/main" id="{B1239431-A065-48A8-B636-D111593D4A39}"/>
+                <a16:creationId xmlns:a16="http://schemas.microsoft.com/office/drawing/2014/main" id="{F64CCFC9-F5BA-4244-8329-21AC9AE90E4B}"/>
               </a:ext>
             </a:extLst>
           </p:cNvPr>
@@ -6951,7 +6951,7 @@
           <p:cNvPr id="21" name="text">
             <a:extLst xmlns:a="http://schemas.openxmlformats.org/drawingml/2006/main">
               <a:ext uri="{FF2B5EF4-FFF2-40B4-BE49-F238E27FC236}">
-                <a16:creationId xmlns:a16="http://schemas.microsoft.com/office/drawing/2014/main" id="{866C495E-56DB-46FE-9C13-891B43E14B18}"/>
+                <a16:creationId xmlns:a16="http://schemas.microsoft.com/office/drawing/2014/main" id="{D23170D0-7768-4736-8C5A-42F333C87C39}"/>
               </a:ext>
             </a:extLst>
           </p:cNvPr>
@@ -7020,7 +7020,7 @@
           <p:cNvPr id="22" name="card">
             <a:extLst xmlns:a="http://schemas.openxmlformats.org/drawingml/2006/main">
               <a:ext uri="{FF2B5EF4-FFF2-40B4-BE49-F238E27FC236}">
-                <a16:creationId xmlns:a16="http://schemas.microsoft.com/office/drawing/2014/main" id="{5AE8DA87-3A02-413E-8814-75AD4818E97B}"/>
+                <a16:creationId xmlns:a16="http://schemas.microsoft.com/office/drawing/2014/main" id="{0473B7E6-820B-4694-91FB-2ED29ED55B87}"/>
               </a:ext>
             </a:extLst>
           </p:cNvPr>
@@ -7055,7 +7055,7 @@
           <p:cNvPr id="23" name="text">
             <a:extLst xmlns:a="http://schemas.openxmlformats.org/drawingml/2006/main">
               <a:ext uri="{FF2B5EF4-FFF2-40B4-BE49-F238E27FC236}">
-                <a16:creationId xmlns:a16="http://schemas.microsoft.com/office/drawing/2014/main" id="{45791A6E-524A-4F81-8A3B-307ED5E2AB7D}"/>
+                <a16:creationId xmlns:a16="http://schemas.microsoft.com/office/drawing/2014/main" id="{DD758CF9-DFB6-4938-B4A8-3D0B432A12E8}"/>
               </a:ext>
             </a:extLst>
           </p:cNvPr>
@@ -7124,7 +7124,7 @@
           <p:cNvPr id="24" name="text">
             <a:extLst xmlns:a="http://schemas.openxmlformats.org/drawingml/2006/main">
               <a:ext uri="{FF2B5EF4-FFF2-40B4-BE49-F238E27FC236}">
-                <a16:creationId xmlns:a16="http://schemas.microsoft.com/office/drawing/2014/main" id="{6006D5F8-6F43-4FC8-AAB3-0050B580C2FB}"/>
+                <a16:creationId xmlns:a16="http://schemas.microsoft.com/office/drawing/2014/main" id="{42242165-7EE1-4797-BF6D-6C15240338F7}"/>
               </a:ext>
             </a:extLst>
           </p:cNvPr>
@@ -7193,7 +7193,7 @@
           <p:cNvPr id="25" name="text">
             <a:extLst xmlns:a="http://schemas.openxmlformats.org/drawingml/2006/main">
               <a:ext uri="{FF2B5EF4-FFF2-40B4-BE49-F238E27FC236}">
-                <a16:creationId xmlns:a16="http://schemas.microsoft.com/office/drawing/2014/main" id="{3E166C04-4F6D-4B13-A73B-771421E27C92}"/>
+                <a16:creationId xmlns:a16="http://schemas.microsoft.com/office/drawing/2014/main" id="{81D6D235-02BA-4304-80F6-883C18E83C10}"/>
               </a:ext>
             </a:extLst>
           </p:cNvPr>
@@ -7262,7 +7262,7 @@
           <p:cNvPr id="26" name="card">
             <a:extLst xmlns:a="http://schemas.openxmlformats.org/drawingml/2006/main">
               <a:ext uri="{FF2B5EF4-FFF2-40B4-BE49-F238E27FC236}">
-                <a16:creationId xmlns:a16="http://schemas.microsoft.com/office/drawing/2014/main" id="{AC3F212E-E4FB-4E14-9C5B-0176AA728A44}"/>
+                <a16:creationId xmlns:a16="http://schemas.microsoft.com/office/drawing/2014/main" id="{B4E235FF-2FA0-42B2-83B9-1291F47357B9}"/>
               </a:ext>
             </a:extLst>
           </p:cNvPr>
@@ -7295,7 +7295,7 @@
           <p:cNvPr id="27" name="card">
             <a:extLst xmlns:a="http://schemas.openxmlformats.org/drawingml/2006/main">
               <a:ext uri="{FF2B5EF4-FFF2-40B4-BE49-F238E27FC236}">
-                <a16:creationId xmlns:a16="http://schemas.microsoft.com/office/drawing/2014/main" id="{10EF997B-415D-45C6-8EF7-CE80D064CE14}"/>
+                <a16:creationId xmlns:a16="http://schemas.microsoft.com/office/drawing/2014/main" id="{50BD3991-2E2C-406F-95BD-B26421AA941A}"/>
               </a:ext>
             </a:extLst>
           </p:cNvPr>
@@ -7328,7 +7328,7 @@
           <p:cNvPr id="28" name="text">
             <a:extLst xmlns:a="http://schemas.openxmlformats.org/drawingml/2006/main">
               <a:ext uri="{FF2B5EF4-FFF2-40B4-BE49-F238E27FC236}">
-                <a16:creationId xmlns:a16="http://schemas.microsoft.com/office/drawing/2014/main" id="{3280AD02-7E15-4989-98AD-264986B09305}"/>
+                <a16:creationId xmlns:a16="http://schemas.microsoft.com/office/drawing/2014/main" id="{390E2353-5850-4466-9558-F12C41638752}"/>
               </a:ext>
             </a:extLst>
           </p:cNvPr>
@@ -7397,7 +7397,7 @@
           <p:cNvPr id="29" name="text">
             <a:extLst xmlns:a="http://schemas.openxmlformats.org/drawingml/2006/main">
               <a:ext uri="{FF2B5EF4-FFF2-40B4-BE49-F238E27FC236}">
-                <a16:creationId xmlns:a16="http://schemas.microsoft.com/office/drawing/2014/main" id="{69CD177A-FC58-48CF-BAF5-D1F894C84E94}"/>
+                <a16:creationId xmlns:a16="http://schemas.microsoft.com/office/drawing/2014/main" id="{D0EE683E-DA51-4770-87FC-5EC0E31FDBA3}"/>
               </a:ext>
             </a:extLst>
           </p:cNvPr>
@@ -7466,7 +7466,7 @@
           <p:cNvPr id="30" name="card">
             <a:extLst xmlns:a="http://schemas.openxmlformats.org/drawingml/2006/main">
               <a:ext uri="{FF2B5EF4-FFF2-40B4-BE49-F238E27FC236}">
-                <a16:creationId xmlns:a16="http://schemas.microsoft.com/office/drawing/2014/main" id="{F2AD6E67-207F-46B3-9841-F865262EC354}"/>
+                <a16:creationId xmlns:a16="http://schemas.microsoft.com/office/drawing/2014/main" id="{C37F1292-EBF1-4A4E-8C55-800E7AC119A0}"/>
               </a:ext>
             </a:extLst>
           </p:cNvPr>
@@ -7499,7 +7499,7 @@
           <p:cNvPr id="31" name="card">
             <a:extLst xmlns:a="http://schemas.openxmlformats.org/drawingml/2006/main">
               <a:ext uri="{FF2B5EF4-FFF2-40B4-BE49-F238E27FC236}">
-                <a16:creationId xmlns:a16="http://schemas.microsoft.com/office/drawing/2014/main" id="{9A256DAA-8E17-4171-B43D-4614AA78917D}"/>
+                <a16:creationId xmlns:a16="http://schemas.microsoft.com/office/drawing/2014/main" id="{A08884CC-4AE2-4C17-86D9-B0A2A60292D6}"/>
               </a:ext>
             </a:extLst>
           </p:cNvPr>
@@ -7532,7 +7532,7 @@
           <p:cNvPr id="32" name="text">
             <a:extLst xmlns:a="http://schemas.openxmlformats.org/drawingml/2006/main">
               <a:ext uri="{FF2B5EF4-FFF2-40B4-BE49-F238E27FC236}">
-                <a16:creationId xmlns:a16="http://schemas.microsoft.com/office/drawing/2014/main" id="{1667FB6A-1081-4D6C-B6F9-207876C211CF}"/>
+                <a16:creationId xmlns:a16="http://schemas.microsoft.com/office/drawing/2014/main" id="{6C3A3611-9CF7-412F-A3C6-1E8C86267F76}"/>
               </a:ext>
             </a:extLst>
           </p:cNvPr>
@@ -7601,7 +7601,7 @@
           <p:cNvPr id="33" name="card">
             <a:extLst xmlns:a="http://schemas.openxmlformats.org/drawingml/2006/main">
               <a:ext uri="{FF2B5EF4-FFF2-40B4-BE49-F238E27FC236}">
-                <a16:creationId xmlns:a16="http://schemas.microsoft.com/office/drawing/2014/main" id="{A7A5A427-8A0E-4B5E-9694-0AB134392B24}"/>
+                <a16:creationId xmlns:a16="http://schemas.microsoft.com/office/drawing/2014/main" id="{9D397B83-624D-47E2-AE4F-43D36A6E37B1}"/>
               </a:ext>
             </a:extLst>
           </p:cNvPr>
@@ -7634,19 +7634,19 @@
           <p:cNvPr id="34" name="text">
             <a:extLst xmlns:a="http://schemas.openxmlformats.org/drawingml/2006/main">
               <a:ext uri="{FF2B5EF4-FFF2-40B4-BE49-F238E27FC236}">
-                <a16:creationId xmlns:a16="http://schemas.microsoft.com/office/drawing/2014/main" id="{0D2A9307-17E0-425D-9A68-0E94922C73CC}"/>
-              </a:ext>
-            </a:extLst>
-          </p:cNvPr>
-          <p:cNvSpPr>
-            <a:spLocks xmlns:a="http://schemas.openxmlformats.org/drawingml/2006/main" noGrp="1"/>
-          </p:cNvSpPr>
-          <p:nvPr/>
-        </p:nvSpPr>
-        <p:spPr>
-          <a:xfrm xmlns:a="http://schemas.openxmlformats.org/drawingml/2006/main">
-            <a:off x="8039100" y="3762375"/>
-            <a:ext cx="3238500" cy="333375"/>
+                <a16:creationId xmlns:a16="http://schemas.microsoft.com/office/drawing/2014/main" id="{6DD04C5E-AEE8-45D3-A90F-5224D761160E}"/>
+              </a:ext>
+            </a:extLst>
+          </p:cNvPr>
+          <p:cNvSpPr>
+            <a:spLocks xmlns:a="http://schemas.openxmlformats.org/drawingml/2006/main" noGrp="1"/>
+          </p:cNvSpPr>
+          <p:nvPr/>
+        </p:nvSpPr>
+        <p:spPr>
+          <a:xfrm xmlns:a="http://schemas.openxmlformats.org/drawingml/2006/main">
+            <a:off x="8039100" y="3800475"/>
+            <a:ext cx="3238500" cy="533400"/>
           </a:xfrm>
           <a:prstGeom xmlns:a="http://schemas.openxmlformats.org/drawingml/2006/main" prst="rect">
             <a:avLst/>
@@ -7663,7 +7663,7 @@
           </a:bodyPr>
           <a:lstStyle xmlns:a="http://schemas.openxmlformats.org/drawingml/2006/main">
             <a:defPPr algn="l">
-              <a:defRPr sz="1500" b="1">
+              <a:defRPr sz="1575" b="1">
                 <a:solidFill>
                   <a:srgbClr val="10243A"/>
                 </a:solidFill>
@@ -7675,7 +7675,7 @@
           </a:lstStyle>
           <a:p xmlns:a="http://schemas.openxmlformats.org/drawingml/2006/main">
             <a:pPr algn="l">
-              <a:defRPr sz="1500" b="1">
+              <a:defRPr sz="1575" b="1">
                 <a:solidFill>
                   <a:srgbClr val="10243A"/>
                 </a:solidFill>
@@ -7685,7 +7685,7 @@
               </a:defRPr>
             </a:pPr>
             <a:r>
-              <a:rPr sz="1500" b="1">
+              <a:rPr sz="1575" b="1">
                 <a:solidFill>
                   <a:srgbClr val="10243A"/>
                 </a:solidFill>
@@ -7693,7 +7693,7 @@
                 <a:ea typeface="Arial"/>
                 <a:cs typeface="Arial"/>
               </a:rPr>
-              <a:t>Target the highest-risk 10%</a:t>
+              <a:t>Calibration did not help here</a:t>
             </a:r>
           </a:p>
         </p:txBody>
@@ -7703,19 +7703,19 @@
           <p:cNvPr id="35" name="text">
             <a:extLst xmlns:a="http://schemas.openxmlformats.org/drawingml/2006/main">
               <a:ext uri="{FF2B5EF4-FFF2-40B4-BE49-F238E27FC236}">
-                <a16:creationId xmlns:a16="http://schemas.microsoft.com/office/drawing/2014/main" id="{17BB982A-48AD-4AE4-9B3E-EEE37681612A}"/>
-              </a:ext>
-            </a:extLst>
-          </p:cNvPr>
-          <p:cNvSpPr>
-            <a:spLocks xmlns:a="http://schemas.openxmlformats.org/drawingml/2006/main" noGrp="1"/>
-          </p:cNvSpPr>
-          <p:nvPr/>
-        </p:nvSpPr>
-        <p:spPr>
-          <a:xfrm xmlns:a="http://schemas.openxmlformats.org/drawingml/2006/main">
-            <a:off x="8039100" y="4143375"/>
-            <a:ext cx="3143250" cy="485775"/>
+                <a16:creationId xmlns:a16="http://schemas.microsoft.com/office/drawing/2014/main" id="{2FBD935C-5734-4043-973B-CAF0B6FF1061}"/>
+              </a:ext>
+            </a:extLst>
+          </p:cNvPr>
+          <p:cNvSpPr>
+            <a:spLocks xmlns:a="http://schemas.openxmlformats.org/drawingml/2006/main" noGrp="1"/>
+          </p:cNvSpPr>
+          <p:nvPr/>
+        </p:nvSpPr>
+        <p:spPr>
+          <a:xfrm xmlns:a="http://schemas.openxmlformats.org/drawingml/2006/main">
+            <a:off x="8039100" y="4438650"/>
+            <a:ext cx="3200400" cy="1095375"/>
           </a:xfrm>
           <a:prstGeom xmlns:a="http://schemas.openxmlformats.org/drawingml/2006/main" prst="rect">
             <a:avLst/>
@@ -7732,9 +7732,9 @@
           </a:bodyPr>
           <a:lstStyle xmlns:a="http://schemas.openxmlformats.org/drawingml/2006/main">
             <a:defPPr algn="l">
-              <a:defRPr sz="2625" b="1">
-                <a:solidFill>
-                  <a:srgbClr val="D77832"/>
+              <a:defRPr sz="1125" b="0">
+                <a:solidFill>
+                  <a:srgbClr val="10243A"/>
                 </a:solidFill>
                 <a:latin typeface="Arial"/>
                 <a:ea typeface="Arial"/>
@@ -7744,9 +7744,9 @@
           </a:lstStyle>
           <a:p xmlns:a="http://schemas.openxmlformats.org/drawingml/2006/main">
             <a:pPr algn="l">
-              <a:defRPr sz="2625" b="1">
-                <a:solidFill>
-                  <a:srgbClr val="D77832"/>
+              <a:defRPr sz="1125" b="0">
+                <a:solidFill>
+                  <a:srgbClr val="10243A"/>
                 </a:solidFill>
                 <a:latin typeface="Arial"/>
                 <a:ea typeface="Arial"/>
@@ -7754,15 +7754,15 @@
               </a:defRPr>
             </a:pPr>
             <a:r>
-              <a:rPr sz="2625" b="1">
-                <a:solidFill>
-                  <a:srgbClr val="D77832"/>
+              <a:rPr sz="1125" b="0">
+                <a:solidFill>
+                  <a:srgbClr val="10243A"/>
                 </a:solidFill>
                 <a:latin typeface="Arial"/>
                 <a:ea typeface="Arial"/>
                 <a:cs typeface="Arial"/>
               </a:rPr>
-              <a:t>+$44.6k</a:t>
+              <a:t>On this holdout, calibration slightly worsened Brier score and log loss. Keep the calibrated result only where its threshold behavior is useful; do not assume it improves probabilities.</a:t>
             </a:r>
           </a:p>
         </p:txBody>
@@ -7772,19 +7772,19 @@
           <p:cNvPr id="36" name="text">
             <a:extLst xmlns:a="http://schemas.openxmlformats.org/drawingml/2006/main">
               <a:ext uri="{FF2B5EF4-FFF2-40B4-BE49-F238E27FC236}">
-                <a16:creationId xmlns:a16="http://schemas.microsoft.com/office/drawing/2014/main" id="{9B1CC8BB-0AF5-4626-85C9-4C46831FD358}"/>
-              </a:ext>
-            </a:extLst>
-          </p:cNvPr>
-          <p:cNvSpPr>
-            <a:spLocks xmlns:a="http://schemas.openxmlformats.org/drawingml/2006/main" noGrp="1"/>
-          </p:cNvSpPr>
-          <p:nvPr/>
-        </p:nvSpPr>
-        <p:spPr>
-          <a:xfrm xmlns:a="http://schemas.openxmlformats.org/drawingml/2006/main">
-            <a:off x="8039100" y="4619625"/>
-            <a:ext cx="3238500" cy="323850"/>
+                <a16:creationId xmlns:a16="http://schemas.microsoft.com/office/drawing/2014/main" id="{7041BA30-455B-40F8-B846-4FE9D613B56C}"/>
+              </a:ext>
+            </a:extLst>
+          </p:cNvPr>
+          <p:cNvSpPr>
+            <a:spLocks xmlns:a="http://schemas.openxmlformats.org/drawingml/2006/main" noGrp="1"/>
+          </p:cNvSpPr>
+          <p:nvPr/>
+        </p:nvSpPr>
+        <p:spPr>
+          <a:xfrm xmlns:a="http://schemas.openxmlformats.org/drawingml/2006/main">
+            <a:off x="714375" y="5848350"/>
+            <a:ext cx="10382250" cy="228600"/>
           </a:xfrm>
           <a:prstGeom xmlns:a="http://schemas.openxmlformats.org/drawingml/2006/main" prst="rect">
             <a:avLst/>
@@ -7801,9 +7801,9 @@
           </a:bodyPr>
           <a:lstStyle xmlns:a="http://schemas.openxmlformats.org/drawingml/2006/main">
             <a:defPPr algn="l">
-              <a:defRPr sz="975" b="1">
-                <a:solidFill>
-                  <a:srgbClr val="10243A"/>
+              <a:defRPr sz="1050" b="1">
+                <a:solidFill>
+                  <a:srgbClr val="526579"/>
                 </a:solidFill>
                 <a:latin typeface="Arial"/>
                 <a:ea typeface="Arial"/>
@@ -7813,9 +7813,9 @@
           </a:lstStyle>
           <a:p xmlns:a="http://schemas.openxmlformats.org/drawingml/2006/main">
             <a:pPr algn="l">
-              <a:defRPr sz="975" b="1">
-                <a:solidFill>
-                  <a:srgbClr val="10243A"/>
+              <a:defRPr sz="1050" b="1">
+                <a:solidFill>
+                  <a:srgbClr val="526579"/>
                 </a:solidFill>
                 <a:latin typeface="Arial"/>
                 <a:ea typeface="Arial"/>
@@ -7823,153 +7823,15 @@
               </a:defRPr>
             </a:pPr>
             <a:r>
-              <a:rPr sz="975" b="1">
-                <a:solidFill>
-                  <a:srgbClr val="10243A"/>
+              <a:rPr sz="1050" b="1">
+                <a:solidFill>
+                  <a:srgbClr val="526579"/>
                 </a:solidFill>
                 <a:latin typeface="Arial"/>
                 <a:ea typeface="Arial"/>
                 <a:cs typeface="Arial"/>
               </a:rPr>
-              <a:t>illustrative expected net value  •  +$100.1k vs random</a:t>
-            </a:r>
-          </a:p>
-        </p:txBody>
-      </p:sp>
-      <p:sp>
-        <p:nvSpPr>
-          <p:cNvPr id="37" name="text">
-            <a:extLst xmlns:a="http://schemas.openxmlformats.org/drawingml/2006/main">
-              <a:ext uri="{FF2B5EF4-FFF2-40B4-BE49-F238E27FC236}">
-                <a16:creationId xmlns:a16="http://schemas.microsoft.com/office/drawing/2014/main" id="{AF7C2003-1DED-467E-BFC6-3C17500BC367}"/>
-              </a:ext>
-            </a:extLst>
-          </p:cNvPr>
-          <p:cNvSpPr>
-            <a:spLocks xmlns:a="http://schemas.openxmlformats.org/drawingml/2006/main" noGrp="1"/>
-          </p:cNvSpPr>
-          <p:nvPr/>
-        </p:nvSpPr>
-        <p:spPr>
-          <a:xfrm xmlns:a="http://schemas.openxmlformats.org/drawingml/2006/main">
-            <a:off x="8039100" y="4991100"/>
-            <a:ext cx="3219450" cy="447675"/>
-          </a:xfrm>
-          <a:prstGeom xmlns:a="http://schemas.openxmlformats.org/drawingml/2006/main" prst="rect">
-            <a:avLst/>
-          </a:prstGeom>
-          <a:noFill xmlns:a="http://schemas.openxmlformats.org/drawingml/2006/main"/>
-          <a:ln xmlns:a="http://schemas.openxmlformats.org/drawingml/2006/main" w="0">
-            <a:noFill/>
-            <a:prstDash val="solid"/>
-          </a:ln>
-        </p:spPr>
-        <p:txBody>
-          <a:bodyPr xmlns:a="http://schemas.openxmlformats.org/drawingml/2006/main" lIns="0" tIns="0" rIns="0" bIns="0" anchor="ctr">
-            <a:normAutofit fontScale="100000"/>
-          </a:bodyPr>
-          <a:lstStyle xmlns:a="http://schemas.openxmlformats.org/drawingml/2006/main">
-            <a:defPPr algn="l">
-              <a:defRPr sz="900" b="0">
-                <a:solidFill>
-                  <a:srgbClr val="10243A"/>
-                </a:solidFill>
-                <a:latin typeface="Arial"/>
-                <a:ea typeface="Arial"/>
-                <a:cs typeface="Arial"/>
-              </a:defRPr>
-            </a:defPPr>
-          </a:lstStyle>
-          <a:p xmlns:a="http://schemas.openxmlformats.org/drawingml/2006/main">
-            <a:pPr algn="l">
-              <a:defRPr sz="900" b="0">
-                <a:solidFill>
-                  <a:srgbClr val="10243A"/>
-                </a:solidFill>
-                <a:latin typeface="Arial"/>
-                <a:ea typeface="Arial"/>
-                <a:cs typeface="Arial"/>
-              </a:defRPr>
-            </a:pPr>
-            <a:r>
-              <a:rPr sz="900" b="0">
-                <a:solidFill>
-                  <a:srgbClr val="10243A"/>
-                </a:solidFill>
-                <a:latin typeface="Arial"/>
-                <a:ea typeface="Arial"/>
-                <a:cs typeface="Arial"/>
-              </a:rPr>
-              <a:t>59.1% of observed churners captured in 15,000 contacts. Assumes 20% intervention success, $100 retained value and $5 outreach cost.</a:t>
-            </a:r>
-          </a:p>
-        </p:txBody>
-      </p:sp>
-      <p:sp>
-        <p:nvSpPr>
-          <p:cNvPr id="38" name="text">
-            <a:extLst xmlns:a="http://schemas.openxmlformats.org/drawingml/2006/main">
-              <a:ext uri="{FF2B5EF4-FFF2-40B4-BE49-F238E27FC236}">
-                <a16:creationId xmlns:a16="http://schemas.microsoft.com/office/drawing/2014/main" id="{C19E99F0-58AE-49DC-BF7D-E8E49C866A5C}"/>
-              </a:ext>
-            </a:extLst>
-          </p:cNvPr>
-          <p:cNvSpPr>
-            <a:spLocks xmlns:a="http://schemas.openxmlformats.org/drawingml/2006/main" noGrp="1"/>
-          </p:cNvSpPr>
-          <p:nvPr/>
-        </p:nvSpPr>
-        <p:spPr>
-          <a:xfrm xmlns:a="http://schemas.openxmlformats.org/drawingml/2006/main">
-            <a:off x="714375" y="5848350"/>
-            <a:ext cx="10572750" cy="228600"/>
-          </a:xfrm>
-          <a:prstGeom xmlns:a="http://schemas.openxmlformats.org/drawingml/2006/main" prst="rect">
-            <a:avLst/>
-          </a:prstGeom>
-          <a:noFill xmlns:a="http://schemas.openxmlformats.org/drawingml/2006/main"/>
-          <a:ln xmlns:a="http://schemas.openxmlformats.org/drawingml/2006/main" w="0">
-            <a:noFill/>
-            <a:prstDash val="solid"/>
-          </a:ln>
-        </p:spPr>
-        <p:txBody>
-          <a:bodyPr xmlns:a="http://schemas.openxmlformats.org/drawingml/2006/main" lIns="0" tIns="0" rIns="0" bIns="0" anchor="ctr">
-            <a:normAutofit fontScale="100000"/>
-          </a:bodyPr>
-          <a:lstStyle xmlns:a="http://schemas.openxmlformats.org/drawingml/2006/main">
-            <a:defPPr algn="l">
-              <a:defRPr sz="975" b="1">
-                <a:solidFill>
-                  <a:srgbClr val="526579"/>
-                </a:solidFill>
-                <a:latin typeface="Arial"/>
-                <a:ea typeface="Arial"/>
-                <a:cs typeface="Arial"/>
-              </a:defRPr>
-            </a:defPPr>
-          </a:lstStyle>
-          <a:p xmlns:a="http://schemas.openxmlformats.org/drawingml/2006/main">
-            <a:pPr algn="l">
-              <a:defRPr sz="975" b="1">
-                <a:solidFill>
-                  <a:srgbClr val="526579"/>
-                </a:solidFill>
-                <a:latin typeface="Arial"/>
-                <a:ea typeface="Arial"/>
-                <a:cs typeface="Arial"/>
-              </a:defRPr>
-            </a:pPr>
-            <a:r>
-              <a:rPr sz="975" b="1">
-                <a:solidFill>
-                  <a:srgbClr val="526579"/>
-                </a:solidFill>
-                <a:latin typeface="Arial"/>
-                <a:ea typeface="Arial"/>
-                <a:cs typeface="Arial"/>
-              </a:rPr>
-              <a:t>Scenario only—not causal savings. Calibration worsened Brier (0.0578 vs 0.0563) and log loss (0.212 vs 0.201).</a:t>
+              <a:t>At the 0.5 threshold, calibrated churn recall = 29.4% (precision = 74.3%).</a:t>
             </a:r>
           </a:p>
         </p:txBody>
@@ -7977,7 +7839,7 @@
     </p:spTree>
     <p:extLst>
       <p:ext uri="{BB962C8B-B14F-4D97-AF65-F5344CB8AC3E}">
-        <p14:creationId xmlns:p14="http://schemas.microsoft.com/office/powerpoint/2010/main" val="429218267"/>
+        <p14:creationId xmlns:p14="http://schemas.microsoft.com/office/powerpoint/2010/main" val="231358282"/>
       </p:ext>
     </p:extLst>
   </p:cSld>
@@ -8008,7 +7870,7 @@
           <p:cNvPr id="31" name="slide-4-kicker">
             <a:extLst xmlns:a="http://schemas.openxmlformats.org/drawingml/2006/main">
               <a:ext uri="{FF2B5EF4-FFF2-40B4-BE49-F238E27FC236}">
-                <a16:creationId xmlns:a16="http://schemas.microsoft.com/office/drawing/2014/main" id="{CCC40BB3-B465-4A17-B370-3E5B7119175F}"/>
+                <a16:creationId xmlns:a16="http://schemas.microsoft.com/office/drawing/2014/main" id="{83A70AE9-9F51-4D81-8E62-1E69425C8C57}"/>
               </a:ext>
             </a:extLst>
           </p:cNvPr>
@@ -8077,7 +7939,7 @@
           <p:cNvPr id="2" name="slide-4-title">
             <a:extLst xmlns:a="http://schemas.openxmlformats.org/drawingml/2006/main">
               <a:ext uri="{FF2B5EF4-FFF2-40B4-BE49-F238E27FC236}">
-                <a16:creationId xmlns:a16="http://schemas.microsoft.com/office/drawing/2014/main" id="{BC577601-AFB3-4C25-827C-AEAC12747759}"/>
+                <a16:creationId xmlns:a16="http://schemas.microsoft.com/office/drawing/2014/main" id="{0E9DEB72-7B64-4616-90F5-767F8D03244E}"/>
               </a:ext>
             </a:extLst>
           </p:cNvPr>
@@ -8146,7 +8008,7 @@
           <p:cNvPr id="3" name="slide-4-rule">
             <a:extLst xmlns:a="http://schemas.openxmlformats.org/drawingml/2006/main">
               <a:ext uri="{FF2B5EF4-FFF2-40B4-BE49-F238E27FC236}">
-                <a16:creationId xmlns:a16="http://schemas.microsoft.com/office/drawing/2014/main" id="{B4F7511E-C9C7-4EA2-B6D9-5AAD70040BDD}"/>
+                <a16:creationId xmlns:a16="http://schemas.microsoft.com/office/drawing/2014/main" id="{7A7D44B3-E7E4-4CED-BDEE-04A8642516E0}"/>
               </a:ext>
             </a:extLst>
           </p:cNvPr>
@@ -8177,7 +8039,7 @@
           <p:cNvPr id="4" name="text">
             <a:extLst xmlns:a="http://schemas.openxmlformats.org/drawingml/2006/main">
               <a:ext uri="{FF2B5EF4-FFF2-40B4-BE49-F238E27FC236}">
-                <a16:creationId xmlns:a16="http://schemas.microsoft.com/office/drawing/2014/main" id="{810B66CF-C2BD-475C-984D-6C6F32B18CFF}"/>
+                <a16:creationId xmlns:a16="http://schemas.microsoft.com/office/drawing/2014/main" id="{DFF26190-3F4F-42AF-B129-E583EE31B466}"/>
               </a:ext>
             </a:extLst>
           </p:cNvPr>
@@ -8246,7 +8108,7 @@
           <p:cNvPr id="5" name="text">
             <a:extLst xmlns:a="http://schemas.openxmlformats.org/drawingml/2006/main">
               <a:ext uri="{FF2B5EF4-FFF2-40B4-BE49-F238E27FC236}">
-                <a16:creationId xmlns:a16="http://schemas.microsoft.com/office/drawing/2014/main" id="{37AFEDED-A7BB-4B24-BFAE-A1DA072B4290}"/>
+                <a16:creationId xmlns:a16="http://schemas.microsoft.com/office/drawing/2014/main" id="{8B50B62B-F559-4971-9785-FE9247050C35}"/>
               </a:ext>
             </a:extLst>
           </p:cNvPr>
@@ -8315,7 +8177,7 @@
           <p:cNvPr id="6" name="text">
             <a:extLst xmlns:a="http://schemas.openxmlformats.org/drawingml/2006/main">
               <a:ext uri="{FF2B5EF4-FFF2-40B4-BE49-F238E27FC236}">
-                <a16:creationId xmlns:a16="http://schemas.microsoft.com/office/drawing/2014/main" id="{5A074831-2FD9-40EF-9D35-20B470363CD6}"/>
+                <a16:creationId xmlns:a16="http://schemas.microsoft.com/office/drawing/2014/main" id="{E18F8D17-C449-45BB-AC30-7B4FB149C8B3}"/>
               </a:ext>
             </a:extLst>
           </p:cNvPr>
@@ -8384,7 +8246,7 @@
           <p:cNvPr id="7" name="">
             <a:extLst xmlns:a="http://schemas.openxmlformats.org/drawingml/2006/main">
               <a:ext uri="{FF2B5EF4-FFF2-40B4-BE49-F238E27FC236}">
-                <a16:creationId xmlns:a16="http://schemas.microsoft.com/office/drawing/2014/main" id="{7D848671-7E04-49DD-BFDB-AC73FF2476B0}"/>
+                <a16:creationId xmlns:a16="http://schemas.microsoft.com/office/drawing/2014/main" id="{11EACE32-E9FC-4244-88E3-8395E1BACE4E}"/>
               </a:ext>
             </a:extLst>
           </p:cNvPr>
@@ -8394,7 +8256,7 @@
           <p:nvPr/>
         </p:nvPicPr>
         <p:blipFill>
-          <a:blip xmlns:r="http://schemas.openxmlformats.org/officeDocument/2006/relationships" xmlns:a="http://schemas.openxmlformats.org/drawingml/2006/main" r:embed="R9692075cb5d146f2"/>
+          <a:blip xmlns:r="http://schemas.openxmlformats.org/officeDocument/2006/relationships" xmlns:a="http://schemas.openxmlformats.org/drawingml/2006/main" r:embed="R68f66f43625b457c"/>
           <a:stretch xmlns:a="http://schemas.openxmlformats.org/drawingml/2006/main"/>
         </p:blipFill>
         <p:spPr>
@@ -8412,7 +8274,7 @@
           <p:cNvPr id="8" name="card">
             <a:extLst xmlns:a="http://schemas.openxmlformats.org/drawingml/2006/main">
               <a:ext uri="{FF2B5EF4-FFF2-40B4-BE49-F238E27FC236}">
-                <a16:creationId xmlns:a16="http://schemas.microsoft.com/office/drawing/2014/main" id="{5E8DD06D-746A-484B-9185-6AB27487F84A}"/>
+                <a16:creationId xmlns:a16="http://schemas.microsoft.com/office/drawing/2014/main" id="{EFB3EE0B-AFE7-4FBC-A50B-3490DDA88D82}"/>
               </a:ext>
             </a:extLst>
           </p:cNvPr>
@@ -8447,7 +8309,7 @@
           <p:cNvPr id="9" name="text">
             <a:extLst xmlns:a="http://schemas.openxmlformats.org/drawingml/2006/main">
               <a:ext uri="{FF2B5EF4-FFF2-40B4-BE49-F238E27FC236}">
-                <a16:creationId xmlns:a16="http://schemas.microsoft.com/office/drawing/2014/main" id="{64A5C98F-A97F-4559-8F99-09FBF2DF6F4B}"/>
+                <a16:creationId xmlns:a16="http://schemas.microsoft.com/office/drawing/2014/main" id="{4DE3FB28-75B2-4ABE-9AB0-5A3ED32C235B}"/>
               </a:ext>
             </a:extLst>
           </p:cNvPr>
@@ -8516,7 +8378,7 @@
           <p:cNvPr id="10" name="text">
             <a:extLst xmlns:a="http://schemas.openxmlformats.org/drawingml/2006/main">
               <a:ext uri="{FF2B5EF4-FFF2-40B4-BE49-F238E27FC236}">
-                <a16:creationId xmlns:a16="http://schemas.microsoft.com/office/drawing/2014/main" id="{CC37AABE-DC45-496E-B03B-E5FEC218E93A}"/>
+                <a16:creationId xmlns:a16="http://schemas.microsoft.com/office/drawing/2014/main" id="{C2EE6AB8-CD9E-44F9-BC1B-E9E7BDAAB4EA}"/>
               </a:ext>
             </a:extLst>
           </p:cNvPr>
@@ -8585,7 +8447,7 @@
           <p:cNvPr id="11" name="text">
             <a:extLst xmlns:a="http://schemas.openxmlformats.org/drawingml/2006/main">
               <a:ext uri="{FF2B5EF4-FFF2-40B4-BE49-F238E27FC236}">
-                <a16:creationId xmlns:a16="http://schemas.microsoft.com/office/drawing/2014/main" id="{D6C6D0AC-5DB1-4698-94FE-1E7C16367F84}"/>
+                <a16:creationId xmlns:a16="http://schemas.microsoft.com/office/drawing/2014/main" id="{BBE81483-43F2-4047-A6EE-83EFC592D877}"/>
               </a:ext>
             </a:extLst>
           </p:cNvPr>
@@ -8654,7 +8516,7 @@
           <p:cNvPr id="12" name="text">
             <a:extLst xmlns:a="http://schemas.openxmlformats.org/drawingml/2006/main">
               <a:ext uri="{FF2B5EF4-FFF2-40B4-BE49-F238E27FC236}">
-                <a16:creationId xmlns:a16="http://schemas.microsoft.com/office/drawing/2014/main" id="{64FB62C1-EC0D-4BDD-9A8C-F0F6DBF61A84}"/>
+                <a16:creationId xmlns:a16="http://schemas.microsoft.com/office/drawing/2014/main" id="{1FA1056C-C2F4-4619-9F22-94FF74256D83}"/>
               </a:ext>
             </a:extLst>
           </p:cNvPr>
@@ -8723,7 +8585,7 @@
           <p:cNvPr id="13" name="card">
             <a:extLst xmlns:a="http://schemas.openxmlformats.org/drawingml/2006/main">
               <a:ext uri="{FF2B5EF4-FFF2-40B4-BE49-F238E27FC236}">
-                <a16:creationId xmlns:a16="http://schemas.microsoft.com/office/drawing/2014/main" id="{8016C294-A260-4264-A433-2411228D704A}"/>
+                <a16:creationId xmlns:a16="http://schemas.microsoft.com/office/drawing/2014/main" id="{628A3F92-5C66-49FE-BE65-4011D0FF5492}"/>
               </a:ext>
             </a:extLst>
           </p:cNvPr>
@@ -8754,7 +8616,7 @@
           <p:cNvPr id="14" name="text">
             <a:extLst xmlns:a="http://schemas.openxmlformats.org/drawingml/2006/main">
               <a:ext uri="{FF2B5EF4-FFF2-40B4-BE49-F238E27FC236}">
-                <a16:creationId xmlns:a16="http://schemas.microsoft.com/office/drawing/2014/main" id="{0AA94D27-07A1-4973-AD6B-B6D874B21599}"/>
+                <a16:creationId xmlns:a16="http://schemas.microsoft.com/office/drawing/2014/main" id="{0E2E4D7D-2E7E-4707-A12E-CD55F6CEDDC8}"/>
               </a:ext>
             </a:extLst>
           </p:cNvPr>
@@ -8823,7 +8685,7 @@
           <p:cNvPr id="15" name="text">
             <a:extLst xmlns:a="http://schemas.openxmlformats.org/drawingml/2006/main">
               <a:ext uri="{FF2B5EF4-FFF2-40B4-BE49-F238E27FC236}">
-                <a16:creationId xmlns:a16="http://schemas.microsoft.com/office/drawing/2014/main" id="{21032E70-EA6B-47C7-BCB1-783972650CA3}"/>
+                <a16:creationId xmlns:a16="http://schemas.microsoft.com/office/drawing/2014/main" id="{E109A7C7-8003-4191-94F4-38B80284B0E5}"/>
               </a:ext>
             </a:extLst>
           </p:cNvPr>
@@ -8892,7 +8754,7 @@
           <p:cNvPr id="16" name="text">
             <a:extLst xmlns:a="http://schemas.openxmlformats.org/drawingml/2006/main">
               <a:ext uri="{FF2B5EF4-FFF2-40B4-BE49-F238E27FC236}">
-                <a16:creationId xmlns:a16="http://schemas.microsoft.com/office/drawing/2014/main" id="{E6277BA0-47E6-416E-83AC-66B2330FCD80}"/>
+                <a16:creationId xmlns:a16="http://schemas.microsoft.com/office/drawing/2014/main" id="{DC04A34C-3C1D-47CB-BB2D-E02960E8B2A1}"/>
               </a:ext>
             </a:extLst>
           </p:cNvPr>
@@ -8961,7 +8823,7 @@
           <p:cNvPr id="17" name="card">
             <a:extLst xmlns:a="http://schemas.openxmlformats.org/drawingml/2006/main">
               <a:ext uri="{FF2B5EF4-FFF2-40B4-BE49-F238E27FC236}">
-                <a16:creationId xmlns:a16="http://schemas.microsoft.com/office/drawing/2014/main" id="{6BA71A23-405E-46A8-AAA2-64AEFDD548AE}"/>
+                <a16:creationId xmlns:a16="http://schemas.microsoft.com/office/drawing/2014/main" id="{665960A5-F15A-41B4-8DA8-E37A2D028944}"/>
               </a:ext>
             </a:extLst>
           </p:cNvPr>
@@ -8992,7 +8854,7 @@
           <p:cNvPr id="18" name="text">
             <a:extLst xmlns:a="http://schemas.openxmlformats.org/drawingml/2006/main">
               <a:ext uri="{FF2B5EF4-FFF2-40B4-BE49-F238E27FC236}">
-                <a16:creationId xmlns:a16="http://schemas.microsoft.com/office/drawing/2014/main" id="{2C91A7D1-F490-4A09-B110-788634DB48A3}"/>
+                <a16:creationId xmlns:a16="http://schemas.microsoft.com/office/drawing/2014/main" id="{09D52FB9-EAC8-4558-AE18-9ADB475F0B76}"/>
               </a:ext>
             </a:extLst>
           </p:cNvPr>
@@ -9061,7 +8923,7 @@
           <p:cNvPr id="19" name="text">
             <a:extLst xmlns:a="http://schemas.openxmlformats.org/drawingml/2006/main">
               <a:ext uri="{FF2B5EF4-FFF2-40B4-BE49-F238E27FC236}">
-                <a16:creationId xmlns:a16="http://schemas.microsoft.com/office/drawing/2014/main" id="{AE8D9B17-C1C2-4028-904B-CF8FB950C339}"/>
+                <a16:creationId xmlns:a16="http://schemas.microsoft.com/office/drawing/2014/main" id="{1E2ACE55-C8E8-4371-99C1-C241EEF6CBC3}"/>
               </a:ext>
             </a:extLst>
           </p:cNvPr>
@@ -9130,7 +8992,7 @@
           <p:cNvPr id="20" name="text">
             <a:extLst xmlns:a="http://schemas.openxmlformats.org/drawingml/2006/main">
               <a:ext uri="{FF2B5EF4-FFF2-40B4-BE49-F238E27FC236}">
-                <a16:creationId xmlns:a16="http://schemas.microsoft.com/office/drawing/2014/main" id="{6F580694-89A2-4354-A918-F7BD1DECD470}"/>
+                <a16:creationId xmlns:a16="http://schemas.microsoft.com/office/drawing/2014/main" id="{D67EFF01-5FD2-4A35-AB0C-75F6870D6FA0}"/>
               </a:ext>
             </a:extLst>
           </p:cNvPr>
@@ -9199,7 +9061,7 @@
           <p:cNvPr id="21" name="card">
             <a:extLst xmlns:a="http://schemas.openxmlformats.org/drawingml/2006/main">
               <a:ext uri="{FF2B5EF4-FFF2-40B4-BE49-F238E27FC236}">
-                <a16:creationId xmlns:a16="http://schemas.microsoft.com/office/drawing/2014/main" id="{B28E5E62-FB5D-48B8-8DF6-06A2D0668553}"/>
+                <a16:creationId xmlns:a16="http://schemas.microsoft.com/office/drawing/2014/main" id="{439AA862-D94B-4E9A-AE31-BC390744CA3C}"/>
               </a:ext>
             </a:extLst>
           </p:cNvPr>
@@ -9230,7 +9092,7 @@
           <p:cNvPr id="22" name="text">
             <a:extLst xmlns:a="http://schemas.openxmlformats.org/drawingml/2006/main">
               <a:ext uri="{FF2B5EF4-FFF2-40B4-BE49-F238E27FC236}">
-                <a16:creationId xmlns:a16="http://schemas.microsoft.com/office/drawing/2014/main" id="{FC3322A1-9A8F-4352-82C7-8D671C0D0856}"/>
+                <a16:creationId xmlns:a16="http://schemas.microsoft.com/office/drawing/2014/main" id="{79207BF9-A228-4739-BEF3-8F6995515AF8}"/>
               </a:ext>
             </a:extLst>
           </p:cNvPr>
@@ -9299,7 +9161,7 @@
           <p:cNvPr id="23" name="text">
             <a:extLst xmlns:a="http://schemas.openxmlformats.org/drawingml/2006/main">
               <a:ext uri="{FF2B5EF4-FFF2-40B4-BE49-F238E27FC236}">
-                <a16:creationId xmlns:a16="http://schemas.microsoft.com/office/drawing/2014/main" id="{6E8D7667-B78F-4B58-81EA-327E81044C64}"/>
+                <a16:creationId xmlns:a16="http://schemas.microsoft.com/office/drawing/2014/main" id="{E597320A-CB98-41DD-980F-D4FBDF8FAC59}"/>
               </a:ext>
             </a:extLst>
           </p:cNvPr>
@@ -9368,7 +9230,7 @@
           <p:cNvPr id="24" name="text">
             <a:extLst xmlns:a="http://schemas.openxmlformats.org/drawingml/2006/main">
               <a:ext uri="{FF2B5EF4-FFF2-40B4-BE49-F238E27FC236}">
-                <a16:creationId xmlns:a16="http://schemas.microsoft.com/office/drawing/2014/main" id="{629B894D-D67B-4F26-B086-EF6BD94A5CCF}"/>
+                <a16:creationId xmlns:a16="http://schemas.microsoft.com/office/drawing/2014/main" id="{48F2C7BF-DCB2-402E-9AF3-4FB2D83F24D4}"/>
               </a:ext>
             </a:extLst>
           </p:cNvPr>
@@ -9437,7 +9299,7 @@
           <p:cNvPr id="25" name="card">
             <a:extLst xmlns:a="http://schemas.openxmlformats.org/drawingml/2006/main">
               <a:ext uri="{FF2B5EF4-FFF2-40B4-BE49-F238E27FC236}">
-                <a16:creationId xmlns:a16="http://schemas.microsoft.com/office/drawing/2014/main" id="{1C7C2679-4683-4C1D-991E-94D278C0F73B}"/>
+                <a16:creationId xmlns:a16="http://schemas.microsoft.com/office/drawing/2014/main" id="{5098FDDD-1F21-4447-915A-084A641F386F}"/>
               </a:ext>
             </a:extLst>
           </p:cNvPr>
@@ -9468,7 +9330,7 @@
           <p:cNvPr id="26" name="text">
             <a:extLst xmlns:a="http://schemas.openxmlformats.org/drawingml/2006/main">
               <a:ext uri="{FF2B5EF4-FFF2-40B4-BE49-F238E27FC236}">
-                <a16:creationId xmlns:a16="http://schemas.microsoft.com/office/drawing/2014/main" id="{60458D48-3EBA-4015-925A-AEE343F09FAB}"/>
+                <a16:creationId xmlns:a16="http://schemas.microsoft.com/office/drawing/2014/main" id="{BE100F87-BE5A-488A-85BE-638B0B2EC4C6}"/>
               </a:ext>
             </a:extLst>
           </p:cNvPr>
@@ -9537,7 +9399,7 @@
           <p:cNvPr id="27" name="text">
             <a:extLst xmlns:a="http://schemas.openxmlformats.org/drawingml/2006/main">
               <a:ext uri="{FF2B5EF4-FFF2-40B4-BE49-F238E27FC236}">
-                <a16:creationId xmlns:a16="http://schemas.microsoft.com/office/drawing/2014/main" id="{54113CF4-BBE8-42D5-9263-74B9979EB50B}"/>
+                <a16:creationId xmlns:a16="http://schemas.microsoft.com/office/drawing/2014/main" id="{DDFB7740-3FB3-446C-B464-83582B9F2A1F}"/>
               </a:ext>
             </a:extLst>
           </p:cNvPr>
@@ -9606,7 +9468,7 @@
           <p:cNvPr id="28" name="text">
             <a:extLst xmlns:a="http://schemas.openxmlformats.org/drawingml/2006/main">
               <a:ext uri="{FF2B5EF4-FFF2-40B4-BE49-F238E27FC236}">
-                <a16:creationId xmlns:a16="http://schemas.microsoft.com/office/drawing/2014/main" id="{5295DC24-BE1F-4A23-9075-2A5AB0AFF987}"/>
+                <a16:creationId xmlns:a16="http://schemas.microsoft.com/office/drawing/2014/main" id="{A521F76F-F8B3-464E-80B5-0104EAFF8E8C}"/>
               </a:ext>
             </a:extLst>
           </p:cNvPr>
@@ -9675,7 +9537,7 @@
           <p:cNvPr id="29" name="card">
             <a:extLst xmlns:a="http://schemas.openxmlformats.org/drawingml/2006/main">
               <a:ext uri="{FF2B5EF4-FFF2-40B4-BE49-F238E27FC236}">
-                <a16:creationId xmlns:a16="http://schemas.microsoft.com/office/drawing/2014/main" id="{AEFCD837-6CF0-49AD-807B-7670A3A32C3B}"/>
+                <a16:creationId xmlns:a16="http://schemas.microsoft.com/office/drawing/2014/main" id="{1E059CAE-59B4-4DA2-AA03-70429EFE1987}"/>
               </a:ext>
             </a:extLst>
           </p:cNvPr>
@@ -9708,7 +9570,7 @@
           <p:cNvPr id="30" name="text">
             <a:extLst xmlns:a="http://schemas.openxmlformats.org/drawingml/2006/main">
               <a:ext uri="{FF2B5EF4-FFF2-40B4-BE49-F238E27FC236}">
-                <a16:creationId xmlns:a16="http://schemas.microsoft.com/office/drawing/2014/main" id="{18E80830-EC58-4B75-BC5B-69796FF5A820}"/>
+                <a16:creationId xmlns:a16="http://schemas.microsoft.com/office/drawing/2014/main" id="{03971C54-1234-4D55-B3F9-1F1888517A7B}"/>
               </a:ext>
             </a:extLst>
           </p:cNvPr>
@@ -9775,7 +9637,7 @@
     </p:spTree>
     <p:extLst>
       <p:ext uri="{BB962C8B-B14F-4D97-AF65-F5344CB8AC3E}">
-        <p14:creationId xmlns:p14="http://schemas.microsoft.com/office/powerpoint/2010/main" val="549933411"/>
+        <p14:creationId xmlns:p14="http://schemas.microsoft.com/office/powerpoint/2010/main" val="857795574"/>
       </p:ext>
     </p:extLst>
   </p:cSld>
@@ -9806,7 +9668,7 @@
           <p:cNvPr id="34" name="slide-5-kicker">
             <a:extLst xmlns:a="http://schemas.openxmlformats.org/drawingml/2006/main">
               <a:ext uri="{FF2B5EF4-FFF2-40B4-BE49-F238E27FC236}">
-                <a16:creationId xmlns:a16="http://schemas.microsoft.com/office/drawing/2014/main" id="{78EB4D42-24EF-42FA-9B27-52B8FA0D498A}"/>
+                <a16:creationId xmlns:a16="http://schemas.microsoft.com/office/drawing/2014/main" id="{15C78A36-600C-4ED2-9593-85F4F8250A34}"/>
               </a:ext>
             </a:extLst>
           </p:cNvPr>
@@ -9875,7 +9737,7 @@
           <p:cNvPr id="2" name="slide-5-title">
             <a:extLst xmlns:a="http://schemas.openxmlformats.org/drawingml/2006/main">
               <a:ext uri="{FF2B5EF4-FFF2-40B4-BE49-F238E27FC236}">
-                <a16:creationId xmlns:a16="http://schemas.microsoft.com/office/drawing/2014/main" id="{082A9077-75D6-4F0A-AAE5-A4A3E4D2A9AF}"/>
+                <a16:creationId xmlns:a16="http://schemas.microsoft.com/office/drawing/2014/main" id="{1C9C151A-F0E7-46C7-B95F-5848740C88FB}"/>
               </a:ext>
             </a:extLst>
           </p:cNvPr>
@@ -9944,7 +9806,7 @@
           <p:cNvPr id="3" name="slide-5-rule">
             <a:extLst xmlns:a="http://schemas.openxmlformats.org/drawingml/2006/main">
               <a:ext uri="{FF2B5EF4-FFF2-40B4-BE49-F238E27FC236}">
-                <a16:creationId xmlns:a16="http://schemas.microsoft.com/office/drawing/2014/main" id="{BD45F38E-799A-4D3F-935A-46B8609D0951}"/>
+                <a16:creationId xmlns:a16="http://schemas.microsoft.com/office/drawing/2014/main" id="{4D2466A5-2570-453E-B5D2-113790C8DED3}"/>
               </a:ext>
             </a:extLst>
           </p:cNvPr>
@@ -9975,7 +9837,7 @@
           <p:cNvPr id="4" name="text">
             <a:extLst xmlns:a="http://schemas.openxmlformats.org/drawingml/2006/main">
               <a:ext uri="{FF2B5EF4-FFF2-40B4-BE49-F238E27FC236}">
-                <a16:creationId xmlns:a16="http://schemas.microsoft.com/office/drawing/2014/main" id="{A97E37CD-87F0-4E95-9FD3-8A0315B88DE6}"/>
+                <a16:creationId xmlns:a16="http://schemas.microsoft.com/office/drawing/2014/main" id="{C5A6EA29-3436-4D1C-B9A1-FF8CADDF318F}"/>
               </a:ext>
             </a:extLst>
           </p:cNvPr>
@@ -10044,7 +9906,7 @@
           <p:cNvPr id="5" name="text">
             <a:extLst xmlns:a="http://schemas.openxmlformats.org/drawingml/2006/main">
               <a:ext uri="{FF2B5EF4-FFF2-40B4-BE49-F238E27FC236}">
-                <a16:creationId xmlns:a16="http://schemas.microsoft.com/office/drawing/2014/main" id="{361EC1F9-E655-4E9F-A472-77E8E68F9197}"/>
+                <a16:creationId xmlns:a16="http://schemas.microsoft.com/office/drawing/2014/main" id="{6D1BCB4A-BC30-44CA-B35D-9B698477ABC3}"/>
               </a:ext>
             </a:extLst>
           </p:cNvPr>
@@ -10113,7 +9975,7 @@
           <p:cNvPr id="6" name="text">
             <a:extLst xmlns:a="http://schemas.openxmlformats.org/drawingml/2006/main">
               <a:ext uri="{FF2B5EF4-FFF2-40B4-BE49-F238E27FC236}">
-                <a16:creationId xmlns:a16="http://schemas.microsoft.com/office/drawing/2014/main" id="{ABE8074C-0F67-4B47-A849-F72C8DBDF60C}"/>
+                <a16:creationId xmlns:a16="http://schemas.microsoft.com/office/drawing/2014/main" id="{00E58A73-A100-44CB-B894-DBFB8D7FA3BE}"/>
               </a:ext>
             </a:extLst>
           </p:cNvPr>
@@ -10182,7 +10044,7 @@
           <p:cNvPr id="7" name="text">
             <a:extLst xmlns:a="http://schemas.openxmlformats.org/drawingml/2006/main">
               <a:ext uri="{FF2B5EF4-FFF2-40B4-BE49-F238E27FC236}">
-                <a16:creationId xmlns:a16="http://schemas.microsoft.com/office/drawing/2014/main" id="{FD11060A-7615-4D35-BB35-F49C9B5676A4}"/>
+                <a16:creationId xmlns:a16="http://schemas.microsoft.com/office/drawing/2014/main" id="{1397ED97-7996-4910-ACDE-200EB2F01B91}"/>
               </a:ext>
             </a:extLst>
           </p:cNvPr>
@@ -10251,7 +10113,7 @@
           <p:cNvPr id="8" name="text">
             <a:extLst xmlns:a="http://schemas.openxmlformats.org/drawingml/2006/main">
               <a:ext uri="{FF2B5EF4-FFF2-40B4-BE49-F238E27FC236}">
-                <a16:creationId xmlns:a16="http://schemas.microsoft.com/office/drawing/2014/main" id="{DE551DCF-B18B-4F98-B37E-DD8743DE67CB}"/>
+                <a16:creationId xmlns:a16="http://schemas.microsoft.com/office/drawing/2014/main" id="{D35C693D-6544-4F96-BF76-DDCE987253A3}"/>
               </a:ext>
             </a:extLst>
           </p:cNvPr>
@@ -10320,7 +10182,7 @@
           <p:cNvPr id="9" name="text">
             <a:extLst xmlns:a="http://schemas.openxmlformats.org/drawingml/2006/main">
               <a:ext uri="{FF2B5EF4-FFF2-40B4-BE49-F238E27FC236}">
-                <a16:creationId xmlns:a16="http://schemas.microsoft.com/office/drawing/2014/main" id="{3C0BD1F5-1461-46E0-91CE-1B85B0539FD4}"/>
+                <a16:creationId xmlns:a16="http://schemas.microsoft.com/office/drawing/2014/main" id="{C31EE3F6-9847-4407-8BBE-D855B1EEF5D5}"/>
               </a:ext>
             </a:extLst>
           </p:cNvPr>
@@ -10332,7 +10194,7 @@
         <p:spPr>
           <a:xfrm xmlns:a="http://schemas.openxmlformats.org/drawingml/2006/main">
             <a:off x="3876675" y="2266950"/>
-            <a:ext cx="2190750" cy="200025"/>
+            <a:ext cx="2571750" cy="200025"/>
           </a:xfrm>
           <a:prstGeom xmlns:a="http://schemas.openxmlformats.org/drawingml/2006/main" prst="rect">
             <a:avLst/>
@@ -10389,7 +10251,7 @@
           <p:cNvPr id="10" name="card">
             <a:extLst xmlns:a="http://schemas.openxmlformats.org/drawingml/2006/main">
               <a:ext uri="{FF2B5EF4-FFF2-40B4-BE49-F238E27FC236}">
-                <a16:creationId xmlns:a16="http://schemas.microsoft.com/office/drawing/2014/main" id="{6734DA73-3544-4576-8364-A53C4B7EA2F2}"/>
+                <a16:creationId xmlns:a16="http://schemas.microsoft.com/office/drawing/2014/main" id="{829341D1-3D21-44C4-A40D-80B4EAF82601}"/>
               </a:ext>
             </a:extLst>
           </p:cNvPr>
@@ -10401,7 +10263,7 @@
         <p:spPr>
           <a:xfrm xmlns:a="http://schemas.openxmlformats.org/drawingml/2006/main">
             <a:off x="3876675" y="2514600"/>
-            <a:ext cx="2190750" cy="190500"/>
+            <a:ext cx="2571750" cy="190500"/>
           </a:xfrm>
           <a:prstGeom xmlns:a="http://schemas.openxmlformats.org/drawingml/2006/main" prst="roundRect">
             <a:avLst>
@@ -10422,7 +10284,7 @@
           <p:cNvPr id="11" name="card">
             <a:extLst xmlns:a="http://schemas.openxmlformats.org/drawingml/2006/main">
               <a:ext uri="{FF2B5EF4-FFF2-40B4-BE49-F238E27FC236}">
-                <a16:creationId xmlns:a16="http://schemas.microsoft.com/office/drawing/2014/main" id="{EE5B39DD-5437-4953-B64E-20E165898CCE}"/>
+                <a16:creationId xmlns:a16="http://schemas.microsoft.com/office/drawing/2014/main" id="{2FDBB03A-7E22-4437-855E-3D98AD026266}"/>
               </a:ext>
             </a:extLst>
           </p:cNvPr>
@@ -10434,7 +10296,7 @@
         <p:spPr>
           <a:xfrm xmlns:a="http://schemas.openxmlformats.org/drawingml/2006/main">
             <a:off x="3876675" y="2514600"/>
-            <a:ext cx="331387" cy="190500"/>
+            <a:ext cx="389020" cy="190500"/>
           </a:xfrm>
           <a:prstGeom xmlns:a="http://schemas.openxmlformats.org/drawingml/2006/main" prst="roundRect">
             <a:avLst>
@@ -10455,19 +10317,19 @@
           <p:cNvPr id="12" name="text">
             <a:extLst xmlns:a="http://schemas.openxmlformats.org/drawingml/2006/main">
               <a:ext uri="{FF2B5EF4-FFF2-40B4-BE49-F238E27FC236}">
-                <a16:creationId xmlns:a16="http://schemas.microsoft.com/office/drawing/2014/main" id="{BB1E9B0F-8C23-4ED7-B55F-680CA4246886}"/>
-              </a:ext>
-            </a:extLst>
-          </p:cNvPr>
-          <p:cNvSpPr>
-            <a:spLocks xmlns:a="http://schemas.openxmlformats.org/drawingml/2006/main" noGrp="1"/>
-          </p:cNvSpPr>
-          <p:nvPr/>
-        </p:nvSpPr>
-        <p:spPr>
-          <a:xfrm xmlns:a="http://schemas.openxmlformats.org/drawingml/2006/main">
-            <a:off x="6181725" y="2447925"/>
-            <a:ext cx="1524000" cy="285750"/>
+                <a16:creationId xmlns:a16="http://schemas.microsoft.com/office/drawing/2014/main" id="{77A1D778-E03E-436A-B73C-5C009C9FE449}"/>
+              </a:ext>
+            </a:extLst>
+          </p:cNvPr>
+          <p:cNvSpPr>
+            <a:spLocks xmlns:a="http://schemas.openxmlformats.org/drawingml/2006/main" noGrp="1"/>
+          </p:cNvSpPr>
+          <p:nvPr/>
+        </p:nvSpPr>
+        <p:spPr>
+          <a:xfrm xmlns:a="http://schemas.openxmlformats.org/drawingml/2006/main">
+            <a:off x="6562725" y="2447925"/>
+            <a:ext cx="952500" cy="285750"/>
           </a:xfrm>
           <a:prstGeom xmlns:a="http://schemas.openxmlformats.org/drawingml/2006/main" prst="rect">
             <a:avLst/>
@@ -10484,7 +10346,7 @@
           </a:bodyPr>
           <a:lstStyle xmlns:a="http://schemas.openxmlformats.org/drawingml/2006/main">
             <a:defPPr algn="l">
-              <a:defRPr sz="900" b="1">
+              <a:defRPr sz="1275" b="1">
                 <a:solidFill>
                   <a:srgbClr val="10243A"/>
                 </a:solidFill>
@@ -10496,7 +10358,7 @@
           </a:lstStyle>
           <a:p xmlns:a="http://schemas.openxmlformats.org/drawingml/2006/main">
             <a:pPr algn="l">
-              <a:defRPr sz="900" b="1">
+              <a:defRPr sz="1275" b="1">
                 <a:solidFill>
                   <a:srgbClr val="10243A"/>
                 </a:solidFill>
@@ -10506,7 +10368,7 @@
               </a:defRPr>
             </a:pPr>
             <a:r>
-              <a:rPr sz="900" b="1">
+              <a:rPr sz="1275" b="1">
                 <a:solidFill>
                   <a:srgbClr val="10243A"/>
                 </a:solidFill>
@@ -10524,7 +10386,7 @@
           <p:cNvPr id="13" name="text">
             <a:extLst xmlns:a="http://schemas.openxmlformats.org/drawingml/2006/main">
               <a:ext uri="{FF2B5EF4-FFF2-40B4-BE49-F238E27FC236}">
-                <a16:creationId xmlns:a16="http://schemas.microsoft.com/office/drawing/2014/main" id="{1AACDAE3-606A-401D-A92C-D2F03D536FD7}"/>
+                <a16:creationId xmlns:a16="http://schemas.microsoft.com/office/drawing/2014/main" id="{A015C343-116D-43F4-AECC-BAEBD1489E5B}"/>
               </a:ext>
             </a:extLst>
           </p:cNvPr>
@@ -10536,7 +10398,7 @@
         <p:spPr>
           <a:xfrm xmlns:a="http://schemas.openxmlformats.org/drawingml/2006/main">
             <a:off x="3876675" y="2771775"/>
-            <a:ext cx="2190750" cy="200025"/>
+            <a:ext cx="2571750" cy="200025"/>
           </a:xfrm>
           <a:prstGeom xmlns:a="http://schemas.openxmlformats.org/drawingml/2006/main" prst="rect">
             <a:avLst/>
@@ -10593,7 +10455,7 @@
           <p:cNvPr id="14" name="card">
             <a:extLst xmlns:a="http://schemas.openxmlformats.org/drawingml/2006/main">
               <a:ext uri="{FF2B5EF4-FFF2-40B4-BE49-F238E27FC236}">
-                <a16:creationId xmlns:a16="http://schemas.microsoft.com/office/drawing/2014/main" id="{1996E924-FD70-4F89-9851-2B97D1067727}"/>
+                <a16:creationId xmlns:a16="http://schemas.microsoft.com/office/drawing/2014/main" id="{AAEA3F21-96B0-422F-9664-84B8F9889941}"/>
               </a:ext>
             </a:extLst>
           </p:cNvPr>
@@ -10605,7 +10467,7 @@
         <p:spPr>
           <a:xfrm xmlns:a="http://schemas.openxmlformats.org/drawingml/2006/main">
             <a:off x="3876675" y="3019425"/>
-            <a:ext cx="2190750" cy="190500"/>
+            <a:ext cx="2571750" cy="190500"/>
           </a:xfrm>
           <a:prstGeom xmlns:a="http://schemas.openxmlformats.org/drawingml/2006/main" prst="roundRect">
             <a:avLst>
@@ -10626,7 +10488,7 @@
           <p:cNvPr id="15" name="card">
             <a:extLst xmlns:a="http://schemas.openxmlformats.org/drawingml/2006/main">
               <a:ext uri="{FF2B5EF4-FFF2-40B4-BE49-F238E27FC236}">
-                <a16:creationId xmlns:a16="http://schemas.microsoft.com/office/drawing/2014/main" id="{9CF4FA66-BD4D-40D0-9D75-C5D223695F78}"/>
+                <a16:creationId xmlns:a16="http://schemas.microsoft.com/office/drawing/2014/main" id="{C8AEDEC3-E703-47FF-848D-C2E536FDB17E}"/>
               </a:ext>
             </a:extLst>
           </p:cNvPr>
@@ -10638,7 +10500,7 @@
         <p:spPr>
           <a:xfrm xmlns:a="http://schemas.openxmlformats.org/drawingml/2006/main">
             <a:off x="3876675" y="3019425"/>
-            <a:ext cx="328588" cy="190500"/>
+            <a:ext cx="385734" cy="190500"/>
           </a:xfrm>
           <a:prstGeom xmlns:a="http://schemas.openxmlformats.org/drawingml/2006/main" prst="roundRect">
             <a:avLst>
@@ -10659,19 +10521,19 @@
           <p:cNvPr id="16" name="text">
             <a:extLst xmlns:a="http://schemas.openxmlformats.org/drawingml/2006/main">
               <a:ext uri="{FF2B5EF4-FFF2-40B4-BE49-F238E27FC236}">
-                <a16:creationId xmlns:a16="http://schemas.microsoft.com/office/drawing/2014/main" id="{FFDEACA6-7287-47A7-9816-FBD356B32048}"/>
-              </a:ext>
-            </a:extLst>
-          </p:cNvPr>
-          <p:cNvSpPr>
-            <a:spLocks xmlns:a="http://schemas.openxmlformats.org/drawingml/2006/main" noGrp="1"/>
-          </p:cNvSpPr>
-          <p:nvPr/>
-        </p:nvSpPr>
-        <p:spPr>
-          <a:xfrm xmlns:a="http://schemas.openxmlformats.org/drawingml/2006/main">
-            <a:off x="6181725" y="2952750"/>
-            <a:ext cx="1524000" cy="285750"/>
+                <a16:creationId xmlns:a16="http://schemas.microsoft.com/office/drawing/2014/main" id="{E74B02A1-3B57-4C75-B7C2-4D05F627FCB7}"/>
+              </a:ext>
+            </a:extLst>
+          </p:cNvPr>
+          <p:cNvSpPr>
+            <a:spLocks xmlns:a="http://schemas.openxmlformats.org/drawingml/2006/main" noGrp="1"/>
+          </p:cNvSpPr>
+          <p:nvPr/>
+        </p:nvSpPr>
+        <p:spPr>
+          <a:xfrm xmlns:a="http://schemas.openxmlformats.org/drawingml/2006/main">
+            <a:off x="6562725" y="2952750"/>
+            <a:ext cx="952500" cy="285750"/>
           </a:xfrm>
           <a:prstGeom xmlns:a="http://schemas.openxmlformats.org/drawingml/2006/main" prst="rect">
             <a:avLst/>
@@ -10688,7 +10550,7 @@
           </a:bodyPr>
           <a:lstStyle xmlns:a="http://schemas.openxmlformats.org/drawingml/2006/main">
             <a:defPPr algn="l">
-              <a:defRPr sz="900" b="1">
+              <a:defRPr sz="1275" b="1">
                 <a:solidFill>
                   <a:srgbClr val="10243A"/>
                 </a:solidFill>
@@ -10700,7 +10562,7 @@
           </a:lstStyle>
           <a:p xmlns:a="http://schemas.openxmlformats.org/drawingml/2006/main">
             <a:pPr algn="l">
-              <a:defRPr sz="900" b="1">
+              <a:defRPr sz="1275" b="1">
                 <a:solidFill>
                   <a:srgbClr val="10243A"/>
                 </a:solidFill>
@@ -10710,7 +10572,7 @@
               </a:defRPr>
             </a:pPr>
             <a:r>
-              <a:rPr sz="900" b="1">
+              <a:rPr sz="1275" b="1">
                 <a:solidFill>
                   <a:srgbClr val="10243A"/>
                 </a:solidFill>
@@ -10728,7 +10590,7 @@
           <p:cNvPr id="17" name="text">
             <a:extLst xmlns:a="http://schemas.openxmlformats.org/drawingml/2006/main">
               <a:ext uri="{FF2B5EF4-FFF2-40B4-BE49-F238E27FC236}">
-                <a16:creationId xmlns:a16="http://schemas.microsoft.com/office/drawing/2014/main" id="{D8D1DFA5-5351-4E93-AECA-7F39C17FAEEA}"/>
+                <a16:creationId xmlns:a16="http://schemas.microsoft.com/office/drawing/2014/main" id="{EC00D1ED-62D2-45A4-8042-C6B50D6F3E7D}"/>
               </a:ext>
             </a:extLst>
           </p:cNvPr>
@@ -10797,7 +10659,7 @@
           <p:cNvPr id="18" name="text">
             <a:extLst xmlns:a="http://schemas.openxmlformats.org/drawingml/2006/main">
               <a:ext uri="{FF2B5EF4-FFF2-40B4-BE49-F238E27FC236}">
-                <a16:creationId xmlns:a16="http://schemas.microsoft.com/office/drawing/2014/main" id="{7C3E3F7A-C8C8-4D97-99F0-86E54C431767}"/>
+                <a16:creationId xmlns:a16="http://schemas.microsoft.com/office/drawing/2014/main" id="{B7715ED4-5FE4-416D-ADA0-22EC1AEC643E}"/>
               </a:ext>
             </a:extLst>
           </p:cNvPr>
@@ -10809,7 +10671,7 @@
         <p:spPr>
           <a:xfrm xmlns:a="http://schemas.openxmlformats.org/drawingml/2006/main">
             <a:off x="3876675" y="3571875"/>
-            <a:ext cx="2190750" cy="200025"/>
+            <a:ext cx="2571750" cy="200025"/>
           </a:xfrm>
           <a:prstGeom xmlns:a="http://schemas.openxmlformats.org/drawingml/2006/main" prst="rect">
             <a:avLst/>
@@ -10866,7 +10728,7 @@
           <p:cNvPr id="19" name="card">
             <a:extLst xmlns:a="http://schemas.openxmlformats.org/drawingml/2006/main">
               <a:ext uri="{FF2B5EF4-FFF2-40B4-BE49-F238E27FC236}">
-                <a16:creationId xmlns:a16="http://schemas.microsoft.com/office/drawing/2014/main" id="{AFB6FB91-3DFC-48BF-ACC2-901997C02A8F}"/>
+                <a16:creationId xmlns:a16="http://schemas.microsoft.com/office/drawing/2014/main" id="{427A220E-6268-4817-9D03-16041214D9F4}"/>
               </a:ext>
             </a:extLst>
           </p:cNvPr>
@@ -10878,7 +10740,7 @@
         <p:spPr>
           <a:xfrm xmlns:a="http://schemas.openxmlformats.org/drawingml/2006/main">
             <a:off x="3876675" y="3819525"/>
-            <a:ext cx="2190750" cy="190500"/>
+            <a:ext cx="2571750" cy="190500"/>
           </a:xfrm>
           <a:prstGeom xmlns:a="http://schemas.openxmlformats.org/drawingml/2006/main" prst="roundRect">
             <a:avLst>
@@ -10899,7 +10761,7 @@
           <p:cNvPr id="20" name="card">
             <a:extLst xmlns:a="http://schemas.openxmlformats.org/drawingml/2006/main">
               <a:ext uri="{FF2B5EF4-FFF2-40B4-BE49-F238E27FC236}">
-                <a16:creationId xmlns:a16="http://schemas.microsoft.com/office/drawing/2014/main" id="{B1FC7B76-5ADE-4C75-8174-51CFB6585AEA}"/>
+                <a16:creationId xmlns:a16="http://schemas.microsoft.com/office/drawing/2014/main" id="{C6E69536-23AB-423D-B908-045E4243F860}"/>
               </a:ext>
             </a:extLst>
           </p:cNvPr>
@@ -10911,7 +10773,7 @@
         <p:spPr>
           <a:xfrm xmlns:a="http://schemas.openxmlformats.org/drawingml/2006/main">
             <a:off x="3876675" y="3819525"/>
-            <a:ext cx="3237" cy="190500"/>
+            <a:ext cx="3800" cy="190500"/>
           </a:xfrm>
           <a:prstGeom xmlns:a="http://schemas.openxmlformats.org/drawingml/2006/main" prst="roundRect">
             <a:avLst>
@@ -10932,19 +10794,19 @@
           <p:cNvPr id="21" name="text">
             <a:extLst xmlns:a="http://schemas.openxmlformats.org/drawingml/2006/main">
               <a:ext uri="{FF2B5EF4-FFF2-40B4-BE49-F238E27FC236}">
-                <a16:creationId xmlns:a16="http://schemas.microsoft.com/office/drawing/2014/main" id="{6B0D1A5E-05D8-4AB8-B461-72A7AA9FF228}"/>
-              </a:ext>
-            </a:extLst>
-          </p:cNvPr>
-          <p:cNvSpPr>
-            <a:spLocks xmlns:a="http://schemas.openxmlformats.org/drawingml/2006/main" noGrp="1"/>
-          </p:cNvSpPr>
-          <p:nvPr/>
-        </p:nvSpPr>
-        <p:spPr>
-          <a:xfrm xmlns:a="http://schemas.openxmlformats.org/drawingml/2006/main">
-            <a:off x="6181725" y="3752850"/>
-            <a:ext cx="1524000" cy="285750"/>
+                <a16:creationId xmlns:a16="http://schemas.microsoft.com/office/drawing/2014/main" id="{5A6721E8-5F32-483D-9FB0-D3043EA8C77C}"/>
+              </a:ext>
+            </a:extLst>
+          </p:cNvPr>
+          <p:cNvSpPr>
+            <a:spLocks xmlns:a="http://schemas.openxmlformats.org/drawingml/2006/main" noGrp="1"/>
+          </p:cNvSpPr>
+          <p:nvPr/>
+        </p:nvSpPr>
+        <p:spPr>
+          <a:xfrm xmlns:a="http://schemas.openxmlformats.org/drawingml/2006/main">
+            <a:off x="6562725" y="3752850"/>
+            <a:ext cx="952500" cy="285750"/>
           </a:xfrm>
           <a:prstGeom xmlns:a="http://schemas.openxmlformats.org/drawingml/2006/main" prst="rect">
             <a:avLst/>
@@ -10961,7 +10823,7 @@
           </a:bodyPr>
           <a:lstStyle xmlns:a="http://schemas.openxmlformats.org/drawingml/2006/main">
             <a:defPPr algn="l">
-              <a:defRPr sz="900" b="1">
+              <a:defRPr sz="1275" b="1">
                 <a:solidFill>
                   <a:srgbClr val="10243A"/>
                 </a:solidFill>
@@ -10973,7 +10835,7 @@
           </a:lstStyle>
           <a:p xmlns:a="http://schemas.openxmlformats.org/drawingml/2006/main">
             <a:pPr algn="l">
-              <a:defRPr sz="900" b="1">
+              <a:defRPr sz="1275" b="1">
                 <a:solidFill>
                   <a:srgbClr val="10243A"/>
                 </a:solidFill>
@@ -10983,7 +10845,7 @@
               </a:defRPr>
             </a:pPr>
             <a:r>
-              <a:rPr sz="900" b="1">
+              <a:rPr sz="1275" b="1">
                 <a:solidFill>
                   <a:srgbClr val="10243A"/>
                 </a:solidFill>
@@ -11001,7 +10863,7 @@
           <p:cNvPr id="22" name="text">
             <a:extLst xmlns:a="http://schemas.openxmlformats.org/drawingml/2006/main">
               <a:ext uri="{FF2B5EF4-FFF2-40B4-BE49-F238E27FC236}">
-                <a16:creationId xmlns:a16="http://schemas.microsoft.com/office/drawing/2014/main" id="{9309CFCA-8BB9-4E94-9557-C9FB061313DD}"/>
+                <a16:creationId xmlns:a16="http://schemas.microsoft.com/office/drawing/2014/main" id="{F792EDEB-5E91-4ABC-BD7E-964B89EC9C5A}"/>
               </a:ext>
             </a:extLst>
           </p:cNvPr>
@@ -11013,7 +10875,7 @@
         <p:spPr>
           <a:xfrm xmlns:a="http://schemas.openxmlformats.org/drawingml/2006/main">
             <a:off x="3876675" y="4076700"/>
-            <a:ext cx="2190750" cy="200025"/>
+            <a:ext cx="2571750" cy="200025"/>
           </a:xfrm>
           <a:prstGeom xmlns:a="http://schemas.openxmlformats.org/drawingml/2006/main" prst="rect">
             <a:avLst/>
@@ -11070,7 +10932,7 @@
           <p:cNvPr id="23" name="card">
             <a:extLst xmlns:a="http://schemas.openxmlformats.org/drawingml/2006/main">
               <a:ext uri="{FF2B5EF4-FFF2-40B4-BE49-F238E27FC236}">
-                <a16:creationId xmlns:a16="http://schemas.microsoft.com/office/drawing/2014/main" id="{0D004BDE-6076-4365-B54A-ED8EBE19E890}"/>
+                <a16:creationId xmlns:a16="http://schemas.microsoft.com/office/drawing/2014/main" id="{45354B28-2842-48DB-BDF3-5FB76F438236}"/>
               </a:ext>
             </a:extLst>
           </p:cNvPr>
@@ -11082,7 +10944,7 @@
         <p:spPr>
           <a:xfrm xmlns:a="http://schemas.openxmlformats.org/drawingml/2006/main">
             <a:off x="3876675" y="4324350"/>
-            <a:ext cx="2190750" cy="190500"/>
+            <a:ext cx="2571750" cy="190500"/>
           </a:xfrm>
           <a:prstGeom xmlns:a="http://schemas.openxmlformats.org/drawingml/2006/main" prst="roundRect">
             <a:avLst>
@@ -11103,7 +10965,7 @@
           <p:cNvPr id="24" name="card">
             <a:extLst xmlns:a="http://schemas.openxmlformats.org/drawingml/2006/main">
               <a:ext uri="{FF2B5EF4-FFF2-40B4-BE49-F238E27FC236}">
-                <a16:creationId xmlns:a16="http://schemas.microsoft.com/office/drawing/2014/main" id="{A9D0CA1C-860F-43EB-97FC-58E9436BA14C}"/>
+                <a16:creationId xmlns:a16="http://schemas.microsoft.com/office/drawing/2014/main" id="{D7030207-35CE-47D4-A894-33F86381DF98}"/>
               </a:ext>
             </a:extLst>
           </p:cNvPr>
@@ -11115,7 +10977,7 @@
         <p:spPr>
           <a:xfrm xmlns:a="http://schemas.openxmlformats.org/drawingml/2006/main">
             <a:off x="3876675" y="4324350"/>
-            <a:ext cx="2053049" cy="190500"/>
+            <a:ext cx="2410101" cy="190500"/>
           </a:xfrm>
           <a:prstGeom xmlns:a="http://schemas.openxmlformats.org/drawingml/2006/main" prst="roundRect">
             <a:avLst>
@@ -11136,19 +10998,19 @@
           <p:cNvPr id="25" name="text">
             <a:extLst xmlns:a="http://schemas.openxmlformats.org/drawingml/2006/main">
               <a:ext uri="{FF2B5EF4-FFF2-40B4-BE49-F238E27FC236}">
-                <a16:creationId xmlns:a16="http://schemas.microsoft.com/office/drawing/2014/main" id="{8979FEA8-1C00-469F-AB7A-FC05C940789D}"/>
-              </a:ext>
-            </a:extLst>
-          </p:cNvPr>
-          <p:cNvSpPr>
-            <a:spLocks xmlns:a="http://schemas.openxmlformats.org/drawingml/2006/main" noGrp="1"/>
-          </p:cNvSpPr>
-          <p:nvPr/>
-        </p:nvSpPr>
-        <p:spPr>
-          <a:xfrm xmlns:a="http://schemas.openxmlformats.org/drawingml/2006/main">
-            <a:off x="6181725" y="4257675"/>
-            <a:ext cx="1524000" cy="285750"/>
+                <a16:creationId xmlns:a16="http://schemas.microsoft.com/office/drawing/2014/main" id="{6343878B-3BC1-46EE-BF29-904F87050317}"/>
+              </a:ext>
+            </a:extLst>
+          </p:cNvPr>
+          <p:cNvSpPr>
+            <a:spLocks xmlns:a="http://schemas.openxmlformats.org/drawingml/2006/main" noGrp="1"/>
+          </p:cNvSpPr>
+          <p:nvPr/>
+        </p:nvSpPr>
+        <p:spPr>
+          <a:xfrm xmlns:a="http://schemas.openxmlformats.org/drawingml/2006/main">
+            <a:off x="6562725" y="4257675"/>
+            <a:ext cx="952500" cy="285750"/>
           </a:xfrm>
           <a:prstGeom xmlns:a="http://schemas.openxmlformats.org/drawingml/2006/main" prst="rect">
             <a:avLst/>
@@ -11165,7 +11027,7 @@
           </a:bodyPr>
           <a:lstStyle xmlns:a="http://schemas.openxmlformats.org/drawingml/2006/main">
             <a:defPPr algn="l">
-              <a:defRPr sz="900" b="1">
+              <a:defRPr sz="1275" b="1">
                 <a:solidFill>
                   <a:srgbClr val="10243A"/>
                 </a:solidFill>
@@ -11177,7 +11039,7 @@
           </a:lstStyle>
           <a:p xmlns:a="http://schemas.openxmlformats.org/drawingml/2006/main">
             <a:pPr algn="l">
-              <a:defRPr sz="900" b="1">
+              <a:defRPr sz="1275" b="1">
                 <a:solidFill>
                   <a:srgbClr val="10243A"/>
                 </a:solidFill>
@@ -11187,7 +11049,7 @@
               </a:defRPr>
             </a:pPr>
             <a:r>
-              <a:rPr sz="900" b="1">
+              <a:rPr sz="1275" b="1">
                 <a:solidFill>
                   <a:srgbClr val="10243A"/>
                 </a:solidFill>
@@ -11195,7 +11057,7 @@
                 <a:ea typeface="Arial"/>
                 <a:cs typeface="Arial"/>
               </a:rPr>
-              <a:t>16.87 pp [15.42–18.38]</a:t>
+              <a:t>16.87 pp [15.4–18.4]</a:t>
             </a:r>
           </a:p>
         </p:txBody>
@@ -11205,7 +11067,7 @@
           <p:cNvPr id="26" name="card">
             <a:extLst xmlns:a="http://schemas.openxmlformats.org/drawingml/2006/main">
               <a:ext uri="{FF2B5EF4-FFF2-40B4-BE49-F238E27FC236}">
-                <a16:creationId xmlns:a16="http://schemas.microsoft.com/office/drawing/2014/main" id="{264F761E-855E-4D29-92A8-87A4F7861D44}"/>
+                <a16:creationId xmlns:a16="http://schemas.microsoft.com/office/drawing/2014/main" id="{64B21870-4E71-4F0C-AAC9-83F1F7DB1BE4}"/>
               </a:ext>
             </a:extLst>
           </p:cNvPr>
@@ -11240,7 +11102,7 @@
           <p:cNvPr id="27" name="text">
             <a:extLst xmlns:a="http://schemas.openxmlformats.org/drawingml/2006/main">
               <a:ext uri="{FF2B5EF4-FFF2-40B4-BE49-F238E27FC236}">
-                <a16:creationId xmlns:a16="http://schemas.microsoft.com/office/drawing/2014/main" id="{54F14718-70C2-4228-943E-405BF17D2491}"/>
+                <a16:creationId xmlns:a16="http://schemas.microsoft.com/office/drawing/2014/main" id="{61831F9E-6DFE-4258-9DFB-3BEEC2875500}"/>
               </a:ext>
             </a:extLst>
           </p:cNvPr>
@@ -11309,7 +11171,7 @@
           <p:cNvPr id="28" name="text">
             <a:extLst xmlns:a="http://schemas.openxmlformats.org/drawingml/2006/main">
               <a:ext uri="{FF2B5EF4-FFF2-40B4-BE49-F238E27FC236}">
-                <a16:creationId xmlns:a16="http://schemas.microsoft.com/office/drawing/2014/main" id="{A6C7D7AD-9FF0-4341-BA74-D6DD97ECA659}"/>
+                <a16:creationId xmlns:a16="http://schemas.microsoft.com/office/drawing/2014/main" id="{F93A9956-5261-41DE-852C-814348158CD9}"/>
               </a:ext>
             </a:extLst>
           </p:cNvPr>
@@ -11378,7 +11240,7 @@
           <p:cNvPr id="29" name="card">
             <a:extLst xmlns:a="http://schemas.openxmlformats.org/drawingml/2006/main">
               <a:ext uri="{FF2B5EF4-FFF2-40B4-BE49-F238E27FC236}">
-                <a16:creationId xmlns:a16="http://schemas.microsoft.com/office/drawing/2014/main" id="{2EE0DD39-6650-4EE1-B25F-CBA0B5066A7A}"/>
+                <a16:creationId xmlns:a16="http://schemas.microsoft.com/office/drawing/2014/main" id="{6BE123C1-B6EB-41CE-A4D6-0A4597C56B31}"/>
               </a:ext>
             </a:extLst>
           </p:cNvPr>
@@ -11411,7 +11273,7 @@
           <p:cNvPr id="30" name="text">
             <a:extLst xmlns:a="http://schemas.openxmlformats.org/drawingml/2006/main">
               <a:ext uri="{FF2B5EF4-FFF2-40B4-BE49-F238E27FC236}">
-                <a16:creationId xmlns:a16="http://schemas.microsoft.com/office/drawing/2014/main" id="{3E254A2B-364C-41AB-B03C-28FF0BB1D839}"/>
+                <a16:creationId xmlns:a16="http://schemas.microsoft.com/office/drawing/2014/main" id="{FAADAFAF-7C9B-461B-97D1-7A1C4E754BA2}"/>
               </a:ext>
             </a:extLst>
           </p:cNvPr>
@@ -11480,7 +11342,7 @@
           <p:cNvPr id="31" name="text">
             <a:extLst xmlns:a="http://schemas.openxmlformats.org/drawingml/2006/main">
               <a:ext uri="{FF2B5EF4-FFF2-40B4-BE49-F238E27FC236}">
-                <a16:creationId xmlns:a16="http://schemas.microsoft.com/office/drawing/2014/main" id="{932E659F-67DD-4FB2-ADB4-7EE38ECC1FCD}"/>
+                <a16:creationId xmlns:a16="http://schemas.microsoft.com/office/drawing/2014/main" id="{C43F8985-D368-4FC2-A3B2-816946D00589}"/>
               </a:ext>
             </a:extLst>
           </p:cNvPr>
@@ -11549,7 +11411,7 @@
           <p:cNvPr id="32" name="text">
             <a:extLst xmlns:a="http://schemas.openxmlformats.org/drawingml/2006/main">
               <a:ext uri="{FF2B5EF4-FFF2-40B4-BE49-F238E27FC236}">
-                <a16:creationId xmlns:a16="http://schemas.microsoft.com/office/drawing/2014/main" id="{D0457198-85DB-43C1-B619-C0DE7B646010}"/>
+                <a16:creationId xmlns:a16="http://schemas.microsoft.com/office/drawing/2014/main" id="{F01AB782-EF2A-4E7F-ABF7-C1510E6C25D2}"/>
               </a:ext>
             </a:extLst>
           </p:cNvPr>
@@ -11618,7 +11480,7 @@
           <p:cNvPr id="33" name="text">
             <a:extLst xmlns:a="http://schemas.openxmlformats.org/drawingml/2006/main">
               <a:ext uri="{FF2B5EF4-FFF2-40B4-BE49-F238E27FC236}">
-                <a16:creationId xmlns:a16="http://schemas.microsoft.com/office/drawing/2014/main" id="{2EE41A6F-9163-49D2-92B8-EF8C570A59F3}"/>
+                <a16:creationId xmlns:a16="http://schemas.microsoft.com/office/drawing/2014/main" id="{87C2CBDD-65FD-4927-A4FD-7CD6073FB81B}"/>
               </a:ext>
             </a:extLst>
           </p:cNvPr>
@@ -11685,7 +11547,7 @@
     </p:spTree>
     <p:extLst>
       <p:ext uri="{BB962C8B-B14F-4D97-AF65-F5344CB8AC3E}">
-        <p14:creationId xmlns:p14="http://schemas.microsoft.com/office/powerpoint/2010/main" val="1996067230"/>
+        <p14:creationId xmlns:p14="http://schemas.microsoft.com/office/powerpoint/2010/main" val="614082356"/>
       </p:ext>
     </p:extLst>
   </p:cSld>
@@ -11716,7 +11578,7 @@
           <p:cNvPr id="26" name="slide-6-kicker">
             <a:extLst xmlns:a="http://schemas.openxmlformats.org/drawingml/2006/main">
               <a:ext uri="{FF2B5EF4-FFF2-40B4-BE49-F238E27FC236}">
-                <a16:creationId xmlns:a16="http://schemas.microsoft.com/office/drawing/2014/main" id="{BAA19148-90A7-4445-BB52-4BCAC6FE1FF8}"/>
+                <a16:creationId xmlns:a16="http://schemas.microsoft.com/office/drawing/2014/main" id="{818CB133-12C7-45DA-80E8-0DE2F89ECEF7}"/>
               </a:ext>
             </a:extLst>
           </p:cNvPr>
@@ -11785,7 +11647,7 @@
           <p:cNvPr id="2" name="slide-6-title">
             <a:extLst xmlns:a="http://schemas.openxmlformats.org/drawingml/2006/main">
               <a:ext uri="{FF2B5EF4-FFF2-40B4-BE49-F238E27FC236}">
-                <a16:creationId xmlns:a16="http://schemas.microsoft.com/office/drawing/2014/main" id="{E786660B-4B46-4453-9F23-098B50382BDC}"/>
+                <a16:creationId xmlns:a16="http://schemas.microsoft.com/office/drawing/2014/main" id="{D01C094C-E8CD-4F04-882C-BCB0174781F4}"/>
               </a:ext>
             </a:extLst>
           </p:cNvPr>
@@ -11854,7 +11716,7 @@
           <p:cNvPr id="3" name="slide-6-rule">
             <a:extLst xmlns:a="http://schemas.openxmlformats.org/drawingml/2006/main">
               <a:ext uri="{FF2B5EF4-FFF2-40B4-BE49-F238E27FC236}">
-                <a16:creationId xmlns:a16="http://schemas.microsoft.com/office/drawing/2014/main" id="{90C0A2CD-8E28-4123-B418-D54E0F2B3DBC}"/>
+                <a16:creationId xmlns:a16="http://schemas.microsoft.com/office/drawing/2014/main" id="{CCBF6259-5617-4CDC-A365-CA0E357DD7E4}"/>
               </a:ext>
             </a:extLst>
           </p:cNvPr>
@@ -11885,7 +11747,7 @@
           <p:cNvPr id="4" name="text">
             <a:extLst xmlns:a="http://schemas.openxmlformats.org/drawingml/2006/main">
               <a:ext uri="{FF2B5EF4-FFF2-40B4-BE49-F238E27FC236}">
-                <a16:creationId xmlns:a16="http://schemas.microsoft.com/office/drawing/2014/main" id="{8FFA2D30-6A7F-4643-955C-8DB0435CF91B}"/>
+                <a16:creationId xmlns:a16="http://schemas.microsoft.com/office/drawing/2014/main" id="{6ABCB398-5FBD-41D2-A313-775094326B58}"/>
               </a:ext>
             </a:extLst>
           </p:cNvPr>
@@ -11954,7 +11816,7 @@
           <p:cNvPr id="5" name="text">
             <a:extLst xmlns:a="http://schemas.openxmlformats.org/drawingml/2006/main">
               <a:ext uri="{FF2B5EF4-FFF2-40B4-BE49-F238E27FC236}">
-                <a16:creationId xmlns:a16="http://schemas.microsoft.com/office/drawing/2014/main" id="{24D80091-6EF4-41BE-AF38-12EB8BF99D38}"/>
+                <a16:creationId xmlns:a16="http://schemas.microsoft.com/office/drawing/2014/main" id="{CA26357E-40E1-4964-82C3-D8FDD88C394B}"/>
               </a:ext>
             </a:extLst>
           </p:cNvPr>
@@ -12023,7 +11885,7 @@
           <p:cNvPr id="6" name="text">
             <a:extLst xmlns:a="http://schemas.openxmlformats.org/drawingml/2006/main">
               <a:ext uri="{FF2B5EF4-FFF2-40B4-BE49-F238E27FC236}">
-                <a16:creationId xmlns:a16="http://schemas.microsoft.com/office/drawing/2014/main" id="{E1B5C6CE-0DD2-4514-A628-6C4365EEF4DB}"/>
+                <a16:creationId xmlns:a16="http://schemas.microsoft.com/office/drawing/2014/main" id="{952B21F7-5A63-419D-BF28-5D87B0B5D34B}"/>
               </a:ext>
             </a:extLst>
           </p:cNvPr>
@@ -12092,7 +11954,7 @@
           <p:cNvPr id="7" name="card">
             <a:extLst xmlns:a="http://schemas.openxmlformats.org/drawingml/2006/main">
               <a:ext uri="{FF2B5EF4-FFF2-40B4-BE49-F238E27FC236}">
-                <a16:creationId xmlns:a16="http://schemas.microsoft.com/office/drawing/2014/main" id="{DF9EBF2C-E979-43C2-869C-F105505D000F}"/>
+                <a16:creationId xmlns:a16="http://schemas.microsoft.com/office/drawing/2014/main" id="{B9C8A45B-F4D8-49B2-87CB-6C93E97C551E}"/>
               </a:ext>
             </a:extLst>
           </p:cNvPr>
@@ -12127,7 +11989,7 @@
           <p:cNvPr id="8" name="card">
             <a:extLst xmlns:a="http://schemas.openxmlformats.org/drawingml/2006/main">
               <a:ext uri="{FF2B5EF4-FFF2-40B4-BE49-F238E27FC236}">
-                <a16:creationId xmlns:a16="http://schemas.microsoft.com/office/drawing/2014/main" id="{8100F794-9A39-451B-A26D-A3D756E71558}"/>
+                <a16:creationId xmlns:a16="http://schemas.microsoft.com/office/drawing/2014/main" id="{BCCA1B68-FEAD-4A9D-863B-86A0A4227C06}"/>
               </a:ext>
             </a:extLst>
           </p:cNvPr>
@@ -12160,7 +12022,7 @@
           <p:cNvPr id="9" name="text">
             <a:extLst xmlns:a="http://schemas.openxmlformats.org/drawingml/2006/main">
               <a:ext uri="{FF2B5EF4-FFF2-40B4-BE49-F238E27FC236}">
-                <a16:creationId xmlns:a16="http://schemas.microsoft.com/office/drawing/2014/main" id="{A2E46C30-BA6A-4D1B-BF77-82B9045AD6DB}"/>
+                <a16:creationId xmlns:a16="http://schemas.microsoft.com/office/drawing/2014/main" id="{E2ECCCA8-40F0-4557-8BB5-51CD2BDC8735}"/>
               </a:ext>
             </a:extLst>
           </p:cNvPr>
@@ -12229,7 +12091,7 @@
           <p:cNvPr id="10" name="text">
             <a:extLst xmlns:a="http://schemas.openxmlformats.org/drawingml/2006/main">
               <a:ext uri="{FF2B5EF4-FFF2-40B4-BE49-F238E27FC236}">
-                <a16:creationId xmlns:a16="http://schemas.microsoft.com/office/drawing/2014/main" id="{54B4B4F7-16A2-4303-9277-370A3E2C7D5C}"/>
+                <a16:creationId xmlns:a16="http://schemas.microsoft.com/office/drawing/2014/main" id="{604221D5-E78F-450E-BA41-2495BC83D488}"/>
               </a:ext>
             </a:extLst>
           </p:cNvPr>
@@ -12298,7 +12160,7 @@
           <p:cNvPr id="11" name="text">
             <a:extLst xmlns:a="http://schemas.openxmlformats.org/drawingml/2006/main">
               <a:ext uri="{FF2B5EF4-FFF2-40B4-BE49-F238E27FC236}">
-                <a16:creationId xmlns:a16="http://schemas.microsoft.com/office/drawing/2014/main" id="{3A2C5C54-B9BB-4913-93FF-490D20ED3031}"/>
+                <a16:creationId xmlns:a16="http://schemas.microsoft.com/office/drawing/2014/main" id="{3E6B4522-2F2E-46D1-9570-23DCF093EC9B}"/>
               </a:ext>
             </a:extLst>
           </p:cNvPr>
@@ -12367,7 +12229,7 @@
           <p:cNvPr id="12" name="card">
             <a:extLst xmlns:a="http://schemas.openxmlformats.org/drawingml/2006/main">
               <a:ext uri="{FF2B5EF4-FFF2-40B4-BE49-F238E27FC236}">
-                <a16:creationId xmlns:a16="http://schemas.microsoft.com/office/drawing/2014/main" id="{7ED679DB-33B7-40FB-82CF-782E2EB718B1}"/>
+                <a16:creationId xmlns:a16="http://schemas.microsoft.com/office/drawing/2014/main" id="{A68C4F61-758D-4D95-8854-3A18EDDBC489}"/>
               </a:ext>
             </a:extLst>
           </p:cNvPr>
@@ -12402,7 +12264,7 @@
           <p:cNvPr id="13" name="card">
             <a:extLst xmlns:a="http://schemas.openxmlformats.org/drawingml/2006/main">
               <a:ext uri="{FF2B5EF4-FFF2-40B4-BE49-F238E27FC236}">
-                <a16:creationId xmlns:a16="http://schemas.microsoft.com/office/drawing/2014/main" id="{7BD46150-F4D6-41EE-A785-D0F6D8150B37}"/>
+                <a16:creationId xmlns:a16="http://schemas.microsoft.com/office/drawing/2014/main" id="{B8D24278-B3A0-4D44-9464-74FADE184492}"/>
               </a:ext>
             </a:extLst>
           </p:cNvPr>
@@ -12435,7 +12297,7 @@
           <p:cNvPr id="14" name="text">
             <a:extLst xmlns:a="http://schemas.openxmlformats.org/drawingml/2006/main">
               <a:ext uri="{FF2B5EF4-FFF2-40B4-BE49-F238E27FC236}">
-                <a16:creationId xmlns:a16="http://schemas.microsoft.com/office/drawing/2014/main" id="{77E6183F-67EF-475F-A916-52686FFB975B}"/>
+                <a16:creationId xmlns:a16="http://schemas.microsoft.com/office/drawing/2014/main" id="{5BD8A14A-EEE7-4CE9-A67E-51544E2D1A79}"/>
               </a:ext>
             </a:extLst>
           </p:cNvPr>
@@ -12504,7 +12366,7 @@
           <p:cNvPr id="15" name="text">
             <a:extLst xmlns:a="http://schemas.openxmlformats.org/drawingml/2006/main">
               <a:ext uri="{FF2B5EF4-FFF2-40B4-BE49-F238E27FC236}">
-                <a16:creationId xmlns:a16="http://schemas.microsoft.com/office/drawing/2014/main" id="{8E375EBE-70D1-46C9-86B7-83F5366C6D46}"/>
+                <a16:creationId xmlns:a16="http://schemas.microsoft.com/office/drawing/2014/main" id="{A284805B-0AEE-4D92-830A-62E5112042C9}"/>
               </a:ext>
             </a:extLst>
           </p:cNvPr>
@@ -12573,7 +12435,7 @@
           <p:cNvPr id="16" name="text">
             <a:extLst xmlns:a="http://schemas.openxmlformats.org/drawingml/2006/main">
               <a:ext uri="{FF2B5EF4-FFF2-40B4-BE49-F238E27FC236}">
-                <a16:creationId xmlns:a16="http://schemas.microsoft.com/office/drawing/2014/main" id="{2A8F12B2-ABC7-442B-A359-45C25EDEFC64}"/>
+                <a16:creationId xmlns:a16="http://schemas.microsoft.com/office/drawing/2014/main" id="{22E0FA4C-AD74-4D74-B46E-4276535E4C19}"/>
               </a:ext>
             </a:extLst>
           </p:cNvPr>
@@ -12642,7 +12504,7 @@
           <p:cNvPr id="17" name="card">
             <a:extLst xmlns:a="http://schemas.openxmlformats.org/drawingml/2006/main">
               <a:ext uri="{FF2B5EF4-FFF2-40B4-BE49-F238E27FC236}">
-                <a16:creationId xmlns:a16="http://schemas.microsoft.com/office/drawing/2014/main" id="{5A58D3F4-BD24-4D0D-89C9-0F42A00A0DF3}"/>
+                <a16:creationId xmlns:a16="http://schemas.microsoft.com/office/drawing/2014/main" id="{62E5E8B1-6CDD-44E0-81BA-6C6E7DB0976A}"/>
               </a:ext>
             </a:extLst>
           </p:cNvPr>
@@ -12677,7 +12539,7 @@
           <p:cNvPr id="18" name="card">
             <a:extLst xmlns:a="http://schemas.openxmlformats.org/drawingml/2006/main">
               <a:ext uri="{FF2B5EF4-FFF2-40B4-BE49-F238E27FC236}">
-                <a16:creationId xmlns:a16="http://schemas.microsoft.com/office/drawing/2014/main" id="{5754C09E-65FE-4E64-9EAF-7B75492D60BC}"/>
+                <a16:creationId xmlns:a16="http://schemas.microsoft.com/office/drawing/2014/main" id="{1C15E533-8EF1-4FA4-9FAB-A54BB036EEDC}"/>
               </a:ext>
             </a:extLst>
           </p:cNvPr>
@@ -12710,7 +12572,7 @@
           <p:cNvPr id="19" name="text">
             <a:extLst xmlns:a="http://schemas.openxmlformats.org/drawingml/2006/main">
               <a:ext uri="{FF2B5EF4-FFF2-40B4-BE49-F238E27FC236}">
-                <a16:creationId xmlns:a16="http://schemas.microsoft.com/office/drawing/2014/main" id="{62A335D8-6D24-4B31-AC30-AD816DFF322B}"/>
+                <a16:creationId xmlns:a16="http://schemas.microsoft.com/office/drawing/2014/main" id="{77699C63-EF2B-450A-BEA9-9C9B65FFD125}"/>
               </a:ext>
             </a:extLst>
           </p:cNvPr>
@@ -12779,7 +12641,7 @@
           <p:cNvPr id="20" name="text">
             <a:extLst xmlns:a="http://schemas.openxmlformats.org/drawingml/2006/main">
               <a:ext uri="{FF2B5EF4-FFF2-40B4-BE49-F238E27FC236}">
-                <a16:creationId xmlns:a16="http://schemas.microsoft.com/office/drawing/2014/main" id="{44B49954-F66F-475B-8603-24344D51616E}"/>
+                <a16:creationId xmlns:a16="http://schemas.microsoft.com/office/drawing/2014/main" id="{F8E48FF8-6072-490A-8756-4E174C144405}"/>
               </a:ext>
             </a:extLst>
           </p:cNvPr>
@@ -12848,7 +12710,7 @@
           <p:cNvPr id="21" name="text">
             <a:extLst xmlns:a="http://schemas.openxmlformats.org/drawingml/2006/main">
               <a:ext uri="{FF2B5EF4-FFF2-40B4-BE49-F238E27FC236}">
-                <a16:creationId xmlns:a16="http://schemas.microsoft.com/office/drawing/2014/main" id="{3E3A9C74-9DA4-4D1E-A5C7-26827B5B8E4D}"/>
+                <a16:creationId xmlns:a16="http://schemas.microsoft.com/office/drawing/2014/main" id="{58FF795C-A7DA-46A0-89DA-93C7D18B8A7F}"/>
               </a:ext>
             </a:extLst>
           </p:cNvPr>
@@ -12917,7 +12779,7 @@
           <p:cNvPr id="22" name="card">
             <a:extLst xmlns:a="http://schemas.openxmlformats.org/drawingml/2006/main">
               <a:ext uri="{FF2B5EF4-FFF2-40B4-BE49-F238E27FC236}">
-                <a16:creationId xmlns:a16="http://schemas.microsoft.com/office/drawing/2014/main" id="{8D0595B5-2693-4900-AFBC-0ECA67184BD6}"/>
+                <a16:creationId xmlns:a16="http://schemas.microsoft.com/office/drawing/2014/main" id="{4FBCB499-DE95-4380-9DFD-461A2149BED7}"/>
               </a:ext>
             </a:extLst>
           </p:cNvPr>
@@ -12950,7 +12812,7 @@
           <p:cNvPr id="23" name="text">
             <a:extLst xmlns:a="http://schemas.openxmlformats.org/drawingml/2006/main">
               <a:ext uri="{FF2B5EF4-FFF2-40B4-BE49-F238E27FC236}">
-                <a16:creationId xmlns:a16="http://schemas.microsoft.com/office/drawing/2014/main" id="{BDB6EEFE-8725-4527-B301-CF26966E4311}"/>
+                <a16:creationId xmlns:a16="http://schemas.microsoft.com/office/drawing/2014/main" id="{A328F4F6-E770-433B-B9CF-9CE86268C5D4}"/>
               </a:ext>
             </a:extLst>
           </p:cNvPr>
@@ -13019,7 +12881,7 @@
           <p:cNvPr id="24" name="text">
             <a:extLst xmlns:a="http://schemas.openxmlformats.org/drawingml/2006/main">
               <a:ext uri="{FF2B5EF4-FFF2-40B4-BE49-F238E27FC236}">
-                <a16:creationId xmlns:a16="http://schemas.microsoft.com/office/drawing/2014/main" id="{60318701-CFAD-4327-9A91-F4C1EF629579}"/>
+                <a16:creationId xmlns:a16="http://schemas.microsoft.com/office/drawing/2014/main" id="{5F016344-EF50-4118-A6A7-0964BD643133}"/>
               </a:ext>
             </a:extLst>
           </p:cNvPr>
@@ -13088,7 +12950,7 @@
           <p:cNvPr id="25" name="text">
             <a:extLst xmlns:a="http://schemas.openxmlformats.org/drawingml/2006/main">
               <a:ext uri="{FF2B5EF4-FFF2-40B4-BE49-F238E27FC236}">
-                <a16:creationId xmlns:a16="http://schemas.microsoft.com/office/drawing/2014/main" id="{9907DEC5-204A-49D2-A676-4F68146A26F0}"/>
+                <a16:creationId xmlns:a16="http://schemas.microsoft.com/office/drawing/2014/main" id="{B5489C78-7B81-4D0B-A714-3BA453CFB687}"/>
               </a:ext>
             </a:extLst>
           </p:cNvPr>
@@ -13155,7 +13017,7 @@
     </p:spTree>
     <p:extLst>
       <p:ext uri="{BB962C8B-B14F-4D97-AF65-F5344CB8AC3E}">
-        <p14:creationId xmlns:p14="http://schemas.microsoft.com/office/powerpoint/2010/main" val="1366973709"/>
+        <p14:creationId xmlns:p14="http://schemas.microsoft.com/office/powerpoint/2010/main" val="975540058"/>
       </p:ext>
     </p:extLst>
   </p:cSld>

</xml_diff>